<commit_message>
Defense Presentation Masterclass: Separated diagrams for visual impact, centralized all slide titles, and implemented a premium Navy Blue branding system with progress tracking.
</commit_message>
<xml_diff>
--- a/presentation/presentation.pptx
+++ b/presentation/presentation.pptx
@@ -17,6 +17,10 @@
     <p:sldId id="265" r:id="rId16"/>
     <p:sldId id="266" r:id="rId17"/>
     <p:sldId id="267" r:id="rId18"/>
+    <p:sldId id="268" r:id="rId19"/>
+    <p:sldId id="269" r:id="rId20"/>
+    <p:sldId id="270" r:id="rId21"/>
+    <p:sldId id="271" r:id="rId22"/>
   </p:sldIdLst>
   <p:sldSz cx="12191695" cy="6858000" type="screen4x3"/>
   <p:notesSz cx="6858000" cy="9144000"/>
@@ -3123,7 +3127,7 @@
           <a:lstStyle/>
           <a:p>
             <a:pPr algn="ctr">
-              <a:defRPr b="1" sz="4800">
+              <a:defRPr b="1" sz="4400">
                 <a:solidFill>
                   <a:srgbClr val="FFFFFF"/>
                 </a:solidFill>
@@ -3151,7 +3155,7 @@
           <a:lstStyle/>
           <a:p>
             <a:pPr algn="ctr">
-              <a:defRPr sz="2800">
+              <a:defRPr sz="2400">
                 <a:solidFill>
                   <a:srgbClr val="FFFFFF"/>
                 </a:solidFill>
@@ -3163,7 +3167,7 @@
           </a:p>
           <a:p>
             <a:pPr algn="ctr">
-              <a:defRPr sz="2800">
+              <a:defRPr sz="2400">
                 <a:solidFill>
                   <a:srgbClr val="FFFFFF"/>
                 </a:solidFill>
@@ -3209,14 +3213,14 @@
           <a:lstStyle/>
           <a:p>
             <a:pPr algn="ctr">
-              <a:defRPr sz="3600" b="1">
+              <a:defRPr sz="3200" b="1">
                 <a:solidFill>
                   <a:srgbClr val="003366"/>
                 </a:solidFill>
               </a:defRPr>
             </a:pPr>
             <a:r>
-              <a:t>Discussion: Structural Robustness &amp; Limitations</a:t>
+              <a:t>Quantitative Evidence: Efficiency &amp; Memory</a:t>
             </a:r>
           </a:p>
         </p:txBody>
@@ -3231,123 +3235,59 @@
             <p:ph idx="1"/>
           </p:nvPr>
         </p:nvSpPr>
-        <p:spPr>
-          <a:xfrm>
-            <a:off x="548640" y="1645920"/>
-            <a:ext cx="10972800" cy="0"/>
-          </a:xfrm>
-        </p:spPr>
+        <p:spPr/>
         <p:txBody>
           <a:bodyPr/>
           <a:lstStyle/>
           <a:p/>
-          <a:p>
-            <a:pPr>
-              <a:spcAft>
-                <a:spcPts val="1200"/>
-              </a:spcAft>
-            </a:pPr>
-            <a:r>
-              <a:rPr sz="2400">
-                <a:solidFill>
-                  <a:srgbClr val="000000"/>
-                </a:solidFill>
-                <a:latin typeface="Calibri"/>
-              </a:rPr>
-              <a:t/>
-            </a:r>
-            <a:r>
-              <a:rPr b="1" sz="2400">
-                <a:solidFill>
-                  <a:srgbClr val="000000"/>
-                </a:solidFill>
-                <a:latin typeface="Calibri"/>
-              </a:rPr>
-              <a:t>Adversarial Complexity</a:t>
-            </a:r>
-            <a:r>
-              <a:rPr sz="2400">
-                <a:solidFill>
-                  <a:srgbClr val="000000"/>
-                </a:solidFill>
-                <a:latin typeface="Calibri"/>
-              </a:rPr>
-              <a:t>: Low absolute ANLS scores reflect the benchmark's focus on high-complexity, multi-column adversarial layouts rather than dataset scale.</a:t>
-            </a:r>
-          </a:p>
-          <a:p>
-            <a:pPr>
-              <a:spcAft>
-                <a:spcPts val="1200"/>
-              </a:spcAft>
-            </a:pPr>
-            <a:r>
-              <a:rPr sz="2400">
-                <a:solidFill>
-                  <a:srgbClr val="000000"/>
-                </a:solidFill>
-                <a:latin typeface="Calibri"/>
-              </a:rPr>
-              <a:t/>
-            </a:r>
-            <a:r>
-              <a:rPr b="1" sz="2400">
-                <a:solidFill>
-                  <a:srgbClr val="000000"/>
-                </a:solidFill>
-                <a:latin typeface="Calibri"/>
-              </a:rPr>
-              <a:t>Computational Overhead</a:t>
-            </a:r>
-            <a:r>
-              <a:rPr sz="2400">
-                <a:solidFill>
-                  <a:srgbClr val="000000"/>
-                </a:solidFill>
-                <a:latin typeface="Calibri"/>
-              </a:rPr>
-              <a:t>: Dual-stream synchronization increases latency, necessitating future GPU-accelerated optimization.</a:t>
-            </a:r>
-          </a:p>
-          <a:p>
-            <a:pPr>
-              <a:spcAft>
-                <a:spcPts val="1200"/>
-              </a:spcAft>
-            </a:pPr>
-            <a:r>
-              <a:rPr sz="2400">
-                <a:solidFill>
-                  <a:srgbClr val="000000"/>
-                </a:solidFill>
-                <a:latin typeface="Calibri"/>
-              </a:rPr>
-              <a:t/>
-            </a:r>
-            <a:r>
-              <a:rPr b="1" sz="2400">
-                <a:solidFill>
-                  <a:srgbClr val="000000"/>
-                </a:solidFill>
-                <a:latin typeface="Calibri"/>
-              </a:rPr>
-              <a:t>Generalization</a:t>
-            </a:r>
-            <a:r>
-              <a:rPr sz="2400">
-                <a:solidFill>
-                  <a:srgbClr val="000000"/>
-                </a:solidFill>
-                <a:latin typeface="Calibri"/>
-              </a:rPr>
-              <a:t>: Reliability performance remains dependent on embedding fidelity and OCR extraction quality.</a:t>
-            </a:r>
-          </a:p>
-        </p:txBody>
-      </p:sp>
-      <p:sp>
-        <p:nvSpPr>
-          <p:cNvPr id="4" name="TextBox 3"/>
+        </p:txBody>
+      </p:sp>
+      <p:sp>
+        <p:nvSpPr>
+          <p:cNvPr id="4" name="Octagon 3"/>
+          <p:cNvSpPr/>
+          <p:nvPr/>
+        </p:nvSpPr>
+        <p:spPr>
+          <a:xfrm>
+            <a:off x="0" y="6766560"/>
+            <a:ext cx="7315017" cy="91440"/>
+          </a:xfrm>
+          <a:prstGeom prst="octagon">
+            <a:avLst/>
+          </a:prstGeom>
+          <a:solidFill>
+            <a:srgbClr val="003366"/>
+          </a:solidFill>
+          <a:ln>
+            <a:noFill/>
+          </a:ln>
+        </p:spPr>
+        <p:style>
+          <a:lnRef idx="1">
+            <a:schemeClr val="accent1"/>
+          </a:lnRef>
+          <a:fillRef idx="3">
+            <a:schemeClr val="accent1"/>
+          </a:fillRef>
+          <a:effectRef idx="2">
+            <a:schemeClr val="accent1"/>
+          </a:effectRef>
+          <a:fontRef idx="minor">
+            <a:schemeClr val="lt1"/>
+          </a:fontRef>
+        </p:style>
+        <p:txBody>
+          <a:bodyPr rtlCol="0" anchor="ctr"/>
+          <a:lstStyle/>
+          <a:p>
+            <a:pPr algn="ctr"/>
+          </a:p>
+        </p:txBody>
+      </p:sp>
+      <p:sp>
+        <p:nvSpPr>
+          <p:cNvPr id="5" name="TextBox 4"/>
           <p:cNvSpPr txBox="1"/>
           <p:nvPr/>
         </p:nvSpPr>
@@ -3368,18 +3308,42 @@
           <a:lstStyle/>
           <a:p>
             <a:pPr algn="r">
-              <a:defRPr sz="1200">
+              <a:defRPr sz="1000">
                 <a:solidFill>
                   <a:srgbClr val="003366"/>
                 </a:solidFill>
               </a:defRPr>
             </a:pPr>
             <a:r>
-              <a:t>9 / 11</a:t>
-            </a:r>
-          </a:p>
-        </p:txBody>
-      </p:sp>
+              <a:t>9 / 15</a:t>
+            </a:r>
+          </a:p>
+        </p:txBody>
+      </p:sp>
+      <p:pic>
+        <p:nvPicPr>
+          <p:cNvPr id="6" name="Picture 5" descr="efficiency_comparison.png"/>
+          <p:cNvPicPr>
+            <a:picLocks noChangeAspect="1"/>
+          </p:cNvPicPr>
+          <p:nvPr/>
+        </p:nvPicPr>
+        <p:blipFill>
+          <a:blip r:embed="rId2"/>
+          <a:stretch>
+            <a:fillRect/>
+          </a:stretch>
+        </p:blipFill>
+        <p:spPr>
+          <a:xfrm>
+            <a:off x="1386687" y="1645920"/>
+            <a:ext cx="9418320" cy="4572000"/>
+          </a:xfrm>
+          <a:prstGeom prst="rect">
+            <a:avLst/>
+          </a:prstGeom>
+        </p:spPr>
+      </p:pic>
     </p:spTree>
   </p:cSld>
   <p:clrMapOvr>
@@ -3414,14 +3378,14 @@
           <a:lstStyle/>
           <a:p>
             <a:pPr algn="ctr">
-              <a:defRPr sz="3600" b="1">
+              <a:defRPr sz="3200" b="1">
                 <a:solidFill>
                   <a:srgbClr val="003366"/>
                 </a:solidFill>
               </a:defRPr>
             </a:pPr>
             <a:r>
-              <a:t>Conclusion and Future Directions</a:t>
+              <a:t>Resource Footprint Analysis</a:t>
             </a:r>
           </a:p>
         </p:txBody>
@@ -3438,8 +3402,8 @@
         </p:nvSpPr>
         <p:spPr>
           <a:xfrm>
-            <a:off x="548640" y="1645920"/>
-            <a:ext cx="10972800" cy="0"/>
+            <a:off x="822960" y="1645920"/>
+            <a:ext cx="10515600" cy="0"/>
           </a:xfrm>
         </p:spPr>
         <p:txBody>
@@ -3447,13 +3411,13 @@
           <a:lstStyle/>
           <a:p/>
           <a:p>
-            <a:pPr>
+            <a:pPr algn="l">
               <a:spcAft>
-                <a:spcPts val="1200"/>
+                <a:spcPts val="1400"/>
               </a:spcAft>
             </a:pPr>
             <a:r>
-              <a:rPr sz="2400">
+              <a:rPr sz="2600">
                 <a:solidFill>
                   <a:srgbClr val="000000"/>
                 </a:solidFill>
@@ -3462,32 +3426,32 @@
               <a:t/>
             </a:r>
             <a:r>
-              <a:rPr b="1" sz="2400">
-                <a:solidFill>
-                  <a:srgbClr val="000000"/>
-                </a:solidFill>
-                <a:latin typeface="Calibri"/>
-              </a:rPr>
-              <a:t>Conclusion</a:t>
-            </a:r>
-            <a:r>
-              <a:rPr sz="2400">
-                <a:solidFill>
-                  <a:srgbClr val="000000"/>
-                </a:solidFill>
-                <a:latin typeface="Calibri"/>
-              </a:rPr>
-              <a:t>: Fusing literal character grounding with semantic layout awareness is essential for mitigating hallucinations in mission-critical Document AI.</a:t>
-            </a:r>
-          </a:p>
-          <a:p>
-            <a:pPr>
+              <a:rPr b="1" sz="2600">
+                <a:solidFill>
+                  <a:srgbClr val="000000"/>
+                </a:solidFill>
+                <a:latin typeface="Calibri"/>
+              </a:rPr>
+              <a:t>Throughput Inversion</a:t>
+            </a:r>
+            <a:r>
+              <a:rPr sz="2600">
+                <a:solidFill>
+                  <a:srgbClr val="000000"/>
+                </a:solidFill>
+                <a:latin typeface="Calibri"/>
+              </a:rPr>
+              <a:t>: While VLMs provide higher throughput, their reliability in zero-shot extractions is significantly lower.</a:t>
+            </a:r>
+          </a:p>
+          <a:p>
+            <a:pPr algn="l">
               <a:spcAft>
-                <a:spcPts val="1200"/>
+                <a:spcPts val="1400"/>
               </a:spcAft>
             </a:pPr>
             <a:r>
-              <a:rPr sz="2400">
+              <a:rPr sz="2600">
                 <a:solidFill>
                   <a:srgbClr val="000000"/>
                 </a:solidFill>
@@ -3496,77 +3460,72 @@
               <a:t/>
             </a:r>
             <a:r>
-              <a:rPr b="1" sz="2400">
-                <a:solidFill>
-                  <a:srgbClr val="000000"/>
-                </a:solidFill>
-                <a:latin typeface="Calibri"/>
-              </a:rPr>
-              <a:t>Future Work</a:t>
-            </a:r>
-            <a:r>
-              <a:rPr sz="2400">
-                <a:solidFill>
-                  <a:srgbClr val="000000"/>
-                </a:solidFill>
-                <a:latin typeface="Calibri"/>
-              </a:rPr>
-              <a:t>:</a:t>
-            </a:r>
-          </a:p>
-          <a:p>
-            <a:pPr>
-              <a:spcAft>
-                <a:spcPts val="1200"/>
-              </a:spcAft>
-            </a:pPr>
-            <a:r>
-              <a:rPr sz="2400">
-                <a:solidFill>
-                  <a:srgbClr val="000000"/>
-                </a:solidFill>
-                <a:latin typeface="Calibri"/>
-              </a:rPr>
-              <a:t>Scaling across dense tabular-specific corpora (TabFact).</a:t>
-            </a:r>
-          </a:p>
-          <a:p>
-            <a:pPr>
-              <a:spcAft>
-                <a:spcPts val="1200"/>
-              </a:spcAft>
-            </a:pPr>
-            <a:r>
-              <a:rPr sz="2400">
-                <a:solidFill>
-                  <a:srgbClr val="000000"/>
-                </a:solidFill>
-                <a:latin typeface="Calibri"/>
-              </a:rPr>
-              <a:t>Investigating natively layout-aware architectures (LayoutLMv3).</a:t>
-            </a:r>
-          </a:p>
-          <a:p>
-            <a:pPr>
-              <a:spcAft>
-                <a:spcPts val="1200"/>
-              </a:spcAft>
-            </a:pPr>
-            <a:r>
-              <a:rPr sz="2400">
-                <a:solidFill>
-                  <a:srgbClr val="000000"/>
-                </a:solidFill>
-                <a:latin typeface="Calibri"/>
-              </a:rPr>
-              <a:t>GPU-accelerated asynchronous tensor processing for reduced latency.</a:t>
-            </a:r>
-          </a:p>
-        </p:txBody>
-      </p:sp>
-      <p:sp>
-        <p:nvSpPr>
-          <p:cNvPr id="4" name="TextBox 3"/>
+              <a:rPr b="1" sz="2600">
+                <a:solidFill>
+                  <a:srgbClr val="000000"/>
+                </a:solidFill>
+                <a:latin typeface="Calibri"/>
+              </a:rPr>
+              <a:t>Memory Consumption</a:t>
+            </a:r>
+            <a:r>
+              <a:rPr sz="2600">
+                <a:solidFill>
+                  <a:srgbClr val="000000"/>
+                </a:solidFill>
+                <a:latin typeface="Calibri"/>
+              </a:rPr>
+              <a:t>: Hybrid models demand higher memory (RSS) due to dual-stream synchronization overhead.</a:t>
+            </a:r>
+          </a:p>
+        </p:txBody>
+      </p:sp>
+      <p:sp>
+        <p:nvSpPr>
+          <p:cNvPr id="4" name="Octagon 3"/>
+          <p:cNvSpPr/>
+          <p:nvPr/>
+        </p:nvSpPr>
+        <p:spPr>
+          <a:xfrm>
+            <a:off x="0" y="6766560"/>
+            <a:ext cx="8127796" cy="91440"/>
+          </a:xfrm>
+          <a:prstGeom prst="octagon">
+            <a:avLst/>
+          </a:prstGeom>
+          <a:solidFill>
+            <a:srgbClr val="003366"/>
+          </a:solidFill>
+          <a:ln>
+            <a:noFill/>
+          </a:ln>
+        </p:spPr>
+        <p:style>
+          <a:lnRef idx="1">
+            <a:schemeClr val="accent1"/>
+          </a:lnRef>
+          <a:fillRef idx="3">
+            <a:schemeClr val="accent1"/>
+          </a:fillRef>
+          <a:effectRef idx="2">
+            <a:schemeClr val="accent1"/>
+          </a:effectRef>
+          <a:fontRef idx="minor">
+            <a:schemeClr val="lt1"/>
+          </a:fontRef>
+        </p:style>
+        <p:txBody>
+          <a:bodyPr rtlCol="0" anchor="ctr"/>
+          <a:lstStyle/>
+          <a:p>
+            <a:pPr algn="ctr"/>
+          </a:p>
+        </p:txBody>
+      </p:sp>
+      <p:sp>
+        <p:nvSpPr>
+          <p:cNvPr id="5" name="TextBox 4"/>
           <p:cNvSpPr txBox="1"/>
           <p:nvPr/>
         </p:nvSpPr>
@@ -3587,14 +3546,14 @@
           <a:lstStyle/>
           <a:p>
             <a:pPr algn="r">
-              <a:defRPr sz="1200">
+              <a:defRPr sz="1000">
                 <a:solidFill>
                   <a:srgbClr val="003366"/>
                 </a:solidFill>
               </a:defRPr>
             </a:pPr>
             <a:r>
-              <a:t>10 / 11</a:t>
+              <a:t>10 / 15</a:t>
             </a:r>
           </a:p>
         </p:txBody>
@@ -3633,14 +3592,14 @@
           <a:lstStyle/>
           <a:p>
             <a:pPr algn="ctr">
-              <a:defRPr sz="3600" b="1">
+              <a:defRPr sz="3200" b="1">
                 <a:solidFill>
                   <a:srgbClr val="003366"/>
                 </a:solidFill>
               </a:defRPr>
             </a:pPr>
             <a:r>
-              <a:t>Thank You</a:t>
+              <a:t>Visualizing Failure Modes: Hallucination Case Study</a:t>
             </a:r>
           </a:p>
         </p:txBody>
@@ -3655,12 +3614,7 @@
             <p:ph idx="1"/>
           </p:nvPr>
         </p:nvSpPr>
-        <p:spPr>
-          <a:xfrm>
-            <a:off x="548640" y="1645920"/>
-            <a:ext cx="10972800" cy="0"/>
-          </a:xfrm>
-        </p:spPr>
+        <p:spPr/>
         <p:txBody>
           <a:bodyPr/>
           <a:lstStyle/>
@@ -3669,7 +3623,50 @@
       </p:sp>
       <p:sp>
         <p:nvSpPr>
-          <p:cNvPr id="4" name="TextBox 3"/>
+          <p:cNvPr id="4" name="Octagon 3"/>
+          <p:cNvSpPr/>
+          <p:nvPr/>
+        </p:nvSpPr>
+        <p:spPr>
+          <a:xfrm>
+            <a:off x="0" y="6766560"/>
+            <a:ext cx="8940576" cy="91440"/>
+          </a:xfrm>
+          <a:prstGeom prst="octagon">
+            <a:avLst/>
+          </a:prstGeom>
+          <a:solidFill>
+            <a:srgbClr val="003366"/>
+          </a:solidFill>
+          <a:ln>
+            <a:noFill/>
+          </a:ln>
+        </p:spPr>
+        <p:style>
+          <a:lnRef idx="1">
+            <a:schemeClr val="accent1"/>
+          </a:lnRef>
+          <a:fillRef idx="3">
+            <a:schemeClr val="accent1"/>
+          </a:fillRef>
+          <a:effectRef idx="2">
+            <a:schemeClr val="accent1"/>
+          </a:effectRef>
+          <a:fontRef idx="minor">
+            <a:schemeClr val="lt1"/>
+          </a:fontRef>
+        </p:style>
+        <p:txBody>
+          <a:bodyPr rtlCol="0" anchor="ctr"/>
+          <a:lstStyle/>
+          <a:p>
+            <a:pPr algn="ctr"/>
+          </a:p>
+        </p:txBody>
+      </p:sp>
+      <p:sp>
+        <p:nvSpPr>
+          <p:cNvPr id="5" name="TextBox 4"/>
           <p:cNvSpPr txBox="1"/>
           <p:nvPr/>
         </p:nvSpPr>
@@ -3690,14 +3687,826 @@
           <a:lstStyle/>
           <a:p>
             <a:pPr algn="r">
-              <a:defRPr sz="1200">
+              <a:defRPr sz="1000">
                 <a:solidFill>
                   <a:srgbClr val="003366"/>
                 </a:solidFill>
               </a:defRPr>
             </a:pPr>
             <a:r>
-              <a:t>11 / 11</a:t>
+              <a:t>11 / 15</a:t>
+            </a:r>
+          </a:p>
+        </p:txBody>
+      </p:sp>
+      <p:pic>
+        <p:nvPicPr>
+          <p:cNvPr id="6" name="Picture 5" descr="hallucination_comparison.png"/>
+          <p:cNvPicPr>
+            <a:picLocks noChangeAspect="1"/>
+          </p:cNvPicPr>
+          <p:nvPr/>
+        </p:nvPicPr>
+        <p:blipFill>
+          <a:blip r:embed="rId2"/>
+          <a:stretch>
+            <a:fillRect/>
+          </a:stretch>
+        </p:blipFill>
+        <p:spPr>
+          <a:xfrm>
+            <a:off x="1386687" y="1645920"/>
+            <a:ext cx="9418320" cy="4572000"/>
+          </a:xfrm>
+          <a:prstGeom prst="rect">
+            <a:avLst/>
+          </a:prstGeom>
+        </p:spPr>
+      </p:pic>
+    </p:spTree>
+  </p:cSld>
+  <p:clrMapOvr>
+    <a:masterClrMapping/>
+  </p:clrMapOvr>
+</p:sld>
+</file>
+
+<file path=ppt/slides/slide13.xml><?xml version="1.0" encoding="utf-8"?>
+<p:sld xmlns:a="http://schemas.openxmlformats.org/drawingml/2006/main" xmlns:p="http://schemas.openxmlformats.org/presentationml/2006/main" xmlns:r="http://schemas.openxmlformats.org/officeDocument/2006/relationships">
+  <p:cSld>
+    <p:spTree>
+      <p:nvGrpSpPr>
+        <p:cNvPr id="1" name=""/>
+        <p:cNvGrpSpPr/>
+        <p:nvPr/>
+      </p:nvGrpSpPr>
+      <p:grpSpPr/>
+      <p:sp>
+        <p:nvSpPr>
+          <p:cNvPr id="2" name="Title 1"/>
+          <p:cNvSpPr>
+            <a:spLocks noGrp="1"/>
+          </p:cNvSpPr>
+          <p:nvPr>
+            <p:ph type="title"/>
+          </p:nvPr>
+        </p:nvSpPr>
+        <p:spPr/>
+        <p:txBody>
+          <a:bodyPr/>
+          <a:lstStyle/>
+          <a:p>
+            <a:pPr algn="ctr">
+              <a:defRPr sz="3200" b="1">
+                <a:solidFill>
+                  <a:srgbClr val="003366"/>
+                </a:solidFill>
+              </a:defRPr>
+            </a:pPr>
+            <a:r>
+              <a:t>Qualitative Analysis: Standalone VLM vs Hybrid</a:t>
+            </a:r>
+          </a:p>
+        </p:txBody>
+      </p:sp>
+      <p:sp>
+        <p:nvSpPr>
+          <p:cNvPr id="3" name="Content Placeholder 2"/>
+          <p:cNvSpPr>
+            <a:spLocks noGrp="1"/>
+          </p:cNvSpPr>
+          <p:nvPr>
+            <p:ph idx="1"/>
+          </p:nvPr>
+        </p:nvSpPr>
+        <p:spPr>
+          <a:xfrm>
+            <a:off x="822960" y="1645920"/>
+            <a:ext cx="10515600" cy="0"/>
+          </a:xfrm>
+        </p:spPr>
+        <p:txBody>
+          <a:bodyPr/>
+          <a:lstStyle/>
+          <a:p/>
+          <a:p>
+            <a:pPr algn="l">
+              <a:spcAft>
+                <a:spcPts val="1400"/>
+              </a:spcAft>
+            </a:pPr>
+            <a:r>
+              <a:rPr sz="2600">
+                <a:solidFill>
+                  <a:srgbClr val="000000"/>
+                </a:solidFill>
+                <a:latin typeface="Calibri"/>
+              </a:rPr>
+              <a:t/>
+            </a:r>
+            <a:r>
+              <a:rPr b="1" sz="2600">
+                <a:solidFill>
+                  <a:srgbClr val="000000"/>
+                </a:solidFill>
+                <a:latin typeface="Calibri"/>
+              </a:rPr>
+              <a:t>VLM Failure</a:t>
+            </a:r>
+            <a:r>
+              <a:rPr sz="2600">
+                <a:solidFill>
+                  <a:srgbClr val="000000"/>
+                </a:solidFill>
+                <a:latin typeface="Calibri"/>
+              </a:rPr>
+              <a:t>: Resolution-loss causes rounding errors and "probabilistic guessing" in financial figures.</a:t>
+            </a:r>
+          </a:p>
+          <a:p>
+            <a:pPr algn="l">
+              <a:spcAft>
+                <a:spcPts val="1400"/>
+              </a:spcAft>
+            </a:pPr>
+            <a:r>
+              <a:rPr sz="2600">
+                <a:solidFill>
+                  <a:srgbClr val="000000"/>
+                </a:solidFill>
+                <a:latin typeface="Calibri"/>
+              </a:rPr>
+              <a:t/>
+            </a:r>
+            <a:r>
+              <a:rPr b="1" sz="2600">
+                <a:solidFill>
+                  <a:srgbClr val="000000"/>
+                </a:solidFill>
+                <a:latin typeface="Calibri"/>
+              </a:rPr>
+              <a:t>Hybrid Remediation</a:t>
+            </a:r>
+            <a:r>
+              <a:rPr sz="2600">
+                <a:solidFill>
+                  <a:srgbClr val="000000"/>
+                </a:solidFill>
+                <a:latin typeface="Calibri"/>
+              </a:rPr>
+              <a:t>: Deterministic OCR grounding recovers exact alphanumeric sequences ($1,240.50$ vs $1,200.00$).</a:t>
+            </a:r>
+          </a:p>
+        </p:txBody>
+      </p:sp>
+      <p:sp>
+        <p:nvSpPr>
+          <p:cNvPr id="4" name="Octagon 3"/>
+          <p:cNvSpPr/>
+          <p:nvPr/>
+        </p:nvSpPr>
+        <p:spPr>
+          <a:xfrm>
+            <a:off x="0" y="6766560"/>
+            <a:ext cx="9753356" cy="91440"/>
+          </a:xfrm>
+          <a:prstGeom prst="octagon">
+            <a:avLst/>
+          </a:prstGeom>
+          <a:solidFill>
+            <a:srgbClr val="003366"/>
+          </a:solidFill>
+          <a:ln>
+            <a:noFill/>
+          </a:ln>
+        </p:spPr>
+        <p:style>
+          <a:lnRef idx="1">
+            <a:schemeClr val="accent1"/>
+          </a:lnRef>
+          <a:fillRef idx="3">
+            <a:schemeClr val="accent1"/>
+          </a:fillRef>
+          <a:effectRef idx="2">
+            <a:schemeClr val="accent1"/>
+          </a:effectRef>
+          <a:fontRef idx="minor">
+            <a:schemeClr val="lt1"/>
+          </a:fontRef>
+        </p:style>
+        <p:txBody>
+          <a:bodyPr rtlCol="0" anchor="ctr"/>
+          <a:lstStyle/>
+          <a:p>
+            <a:pPr algn="ctr"/>
+          </a:p>
+        </p:txBody>
+      </p:sp>
+      <p:sp>
+        <p:nvSpPr>
+          <p:cNvPr id="5" name="TextBox 4"/>
+          <p:cNvSpPr txBox="1"/>
+          <p:nvPr/>
+        </p:nvSpPr>
+        <p:spPr>
+          <a:xfrm>
+            <a:off x="11430000" y="6400800"/>
+            <a:ext cx="731520" cy="365760"/>
+          </a:xfrm>
+          <a:prstGeom prst="rect">
+            <a:avLst/>
+          </a:prstGeom>
+          <a:noFill/>
+        </p:spPr>
+        <p:txBody>
+          <a:bodyPr wrap="none">
+            <a:spAutoFit/>
+          </a:bodyPr>
+          <a:lstStyle/>
+          <a:p>
+            <a:pPr algn="r">
+              <a:defRPr sz="1000">
+                <a:solidFill>
+                  <a:srgbClr val="003366"/>
+                </a:solidFill>
+              </a:defRPr>
+            </a:pPr>
+            <a:r>
+              <a:t>12 / 15</a:t>
+            </a:r>
+          </a:p>
+        </p:txBody>
+      </p:sp>
+    </p:spTree>
+  </p:cSld>
+  <p:clrMapOvr>
+    <a:masterClrMapping/>
+  </p:clrMapOvr>
+</p:sld>
+</file>
+
+<file path=ppt/slides/slide14.xml><?xml version="1.0" encoding="utf-8"?>
+<p:sld xmlns:a="http://schemas.openxmlformats.org/drawingml/2006/main" xmlns:p="http://schemas.openxmlformats.org/presentationml/2006/main" xmlns:r="http://schemas.openxmlformats.org/officeDocument/2006/relationships">
+  <p:cSld>
+    <p:spTree>
+      <p:nvGrpSpPr>
+        <p:cNvPr id="1" name=""/>
+        <p:cNvGrpSpPr/>
+        <p:nvPr/>
+      </p:nvGrpSpPr>
+      <p:grpSpPr/>
+      <p:sp>
+        <p:nvSpPr>
+          <p:cNvPr id="2" name="Title 1"/>
+          <p:cNvSpPr>
+            <a:spLocks noGrp="1"/>
+          </p:cNvSpPr>
+          <p:nvPr>
+            <p:ph type="title"/>
+          </p:nvPr>
+        </p:nvSpPr>
+        <p:spPr/>
+        <p:txBody>
+          <a:bodyPr/>
+          <a:lstStyle/>
+          <a:p>
+            <a:pPr algn="ctr">
+              <a:defRPr sz="3200" b="1">
+                <a:solidFill>
+                  <a:srgbClr val="003366"/>
+                </a:solidFill>
+              </a:defRPr>
+            </a:pPr>
+            <a:r>
+              <a:t>Discussion: Structural Robustness &amp; Limitations</a:t>
+            </a:r>
+          </a:p>
+        </p:txBody>
+      </p:sp>
+      <p:sp>
+        <p:nvSpPr>
+          <p:cNvPr id="3" name="Content Placeholder 2"/>
+          <p:cNvSpPr>
+            <a:spLocks noGrp="1"/>
+          </p:cNvSpPr>
+          <p:nvPr>
+            <p:ph idx="1"/>
+          </p:nvPr>
+        </p:nvSpPr>
+        <p:spPr>
+          <a:xfrm>
+            <a:off x="822960" y="1645920"/>
+            <a:ext cx="10515600" cy="0"/>
+          </a:xfrm>
+        </p:spPr>
+        <p:txBody>
+          <a:bodyPr/>
+          <a:lstStyle/>
+          <a:p/>
+          <a:p>
+            <a:pPr algn="l">
+              <a:spcAft>
+                <a:spcPts val="1400"/>
+              </a:spcAft>
+            </a:pPr>
+            <a:r>
+              <a:rPr sz="2600">
+                <a:solidFill>
+                  <a:srgbClr val="000000"/>
+                </a:solidFill>
+                <a:latin typeface="Calibri"/>
+              </a:rPr>
+              <a:t/>
+            </a:r>
+            <a:r>
+              <a:rPr b="1" sz="2600">
+                <a:solidFill>
+                  <a:srgbClr val="000000"/>
+                </a:solidFill>
+                <a:latin typeface="Calibri"/>
+              </a:rPr>
+              <a:t>Adversarial Complexity</a:t>
+            </a:r>
+            <a:r>
+              <a:rPr sz="2600">
+                <a:solidFill>
+                  <a:srgbClr val="000000"/>
+                </a:solidFill>
+                <a:latin typeface="Calibri"/>
+              </a:rPr>
+              <a:t>: Low ANLS scores reflect the benchmark's focus on high-complexity, multi-column adversarial layouts.</a:t>
+            </a:r>
+          </a:p>
+          <a:p>
+            <a:pPr algn="l">
+              <a:spcAft>
+                <a:spcPts val="1400"/>
+              </a:spcAft>
+            </a:pPr>
+            <a:r>
+              <a:rPr sz="2600">
+                <a:solidFill>
+                  <a:srgbClr val="000000"/>
+                </a:solidFill>
+                <a:latin typeface="Calibri"/>
+              </a:rPr>
+              <a:t/>
+            </a:r>
+            <a:r>
+              <a:rPr b="1" sz="2600">
+                <a:solidFill>
+                  <a:srgbClr val="000000"/>
+                </a:solidFill>
+                <a:latin typeface="Calibri"/>
+              </a:rPr>
+              <a:t>Computational Overhead</a:t>
+            </a:r>
+            <a:r>
+              <a:rPr sz="2600">
+                <a:solidFill>
+                  <a:srgbClr val="000000"/>
+                </a:solidFill>
+                <a:latin typeface="Calibri"/>
+              </a:rPr>
+              <a:t>: Dual-stream synchronization increases latency, necessitating future GPU-accelerated optimization.</a:t>
+            </a:r>
+          </a:p>
+        </p:txBody>
+      </p:sp>
+      <p:sp>
+        <p:nvSpPr>
+          <p:cNvPr id="4" name="Octagon 3"/>
+          <p:cNvSpPr/>
+          <p:nvPr/>
+        </p:nvSpPr>
+        <p:spPr>
+          <a:xfrm>
+            <a:off x="0" y="6766560"/>
+            <a:ext cx="10566135" cy="91440"/>
+          </a:xfrm>
+          <a:prstGeom prst="octagon">
+            <a:avLst/>
+          </a:prstGeom>
+          <a:solidFill>
+            <a:srgbClr val="003366"/>
+          </a:solidFill>
+          <a:ln>
+            <a:noFill/>
+          </a:ln>
+        </p:spPr>
+        <p:style>
+          <a:lnRef idx="1">
+            <a:schemeClr val="accent1"/>
+          </a:lnRef>
+          <a:fillRef idx="3">
+            <a:schemeClr val="accent1"/>
+          </a:fillRef>
+          <a:effectRef idx="2">
+            <a:schemeClr val="accent1"/>
+          </a:effectRef>
+          <a:fontRef idx="minor">
+            <a:schemeClr val="lt1"/>
+          </a:fontRef>
+        </p:style>
+        <p:txBody>
+          <a:bodyPr rtlCol="0" anchor="ctr"/>
+          <a:lstStyle/>
+          <a:p>
+            <a:pPr algn="ctr"/>
+          </a:p>
+        </p:txBody>
+      </p:sp>
+      <p:sp>
+        <p:nvSpPr>
+          <p:cNvPr id="5" name="TextBox 4"/>
+          <p:cNvSpPr txBox="1"/>
+          <p:nvPr/>
+        </p:nvSpPr>
+        <p:spPr>
+          <a:xfrm>
+            <a:off x="11430000" y="6400800"/>
+            <a:ext cx="731520" cy="365760"/>
+          </a:xfrm>
+          <a:prstGeom prst="rect">
+            <a:avLst/>
+          </a:prstGeom>
+          <a:noFill/>
+        </p:spPr>
+        <p:txBody>
+          <a:bodyPr wrap="none">
+            <a:spAutoFit/>
+          </a:bodyPr>
+          <a:lstStyle/>
+          <a:p>
+            <a:pPr algn="r">
+              <a:defRPr sz="1000">
+                <a:solidFill>
+                  <a:srgbClr val="003366"/>
+                </a:solidFill>
+              </a:defRPr>
+            </a:pPr>
+            <a:r>
+              <a:t>13 / 15</a:t>
+            </a:r>
+          </a:p>
+        </p:txBody>
+      </p:sp>
+    </p:spTree>
+  </p:cSld>
+  <p:clrMapOvr>
+    <a:masterClrMapping/>
+  </p:clrMapOvr>
+</p:sld>
+</file>
+
+<file path=ppt/slides/slide15.xml><?xml version="1.0" encoding="utf-8"?>
+<p:sld xmlns:a="http://schemas.openxmlformats.org/drawingml/2006/main" xmlns:p="http://schemas.openxmlformats.org/presentationml/2006/main" xmlns:r="http://schemas.openxmlformats.org/officeDocument/2006/relationships">
+  <p:cSld>
+    <p:spTree>
+      <p:nvGrpSpPr>
+        <p:cNvPr id="1" name=""/>
+        <p:cNvGrpSpPr/>
+        <p:nvPr/>
+      </p:nvGrpSpPr>
+      <p:grpSpPr/>
+      <p:sp>
+        <p:nvSpPr>
+          <p:cNvPr id="2" name="Title 1"/>
+          <p:cNvSpPr>
+            <a:spLocks noGrp="1"/>
+          </p:cNvSpPr>
+          <p:nvPr>
+            <p:ph type="title"/>
+          </p:nvPr>
+        </p:nvSpPr>
+        <p:spPr/>
+        <p:txBody>
+          <a:bodyPr/>
+          <a:lstStyle/>
+          <a:p>
+            <a:pPr algn="ctr">
+              <a:defRPr sz="3200" b="1">
+                <a:solidFill>
+                  <a:srgbClr val="003366"/>
+                </a:solidFill>
+              </a:defRPr>
+            </a:pPr>
+            <a:r>
+              <a:t>Conclusion and Future Directions</a:t>
+            </a:r>
+          </a:p>
+        </p:txBody>
+      </p:sp>
+      <p:sp>
+        <p:nvSpPr>
+          <p:cNvPr id="3" name="Content Placeholder 2"/>
+          <p:cNvSpPr>
+            <a:spLocks noGrp="1"/>
+          </p:cNvSpPr>
+          <p:nvPr>
+            <p:ph idx="1"/>
+          </p:nvPr>
+        </p:nvSpPr>
+        <p:spPr>
+          <a:xfrm>
+            <a:off x="822960" y="1645920"/>
+            <a:ext cx="10515600" cy="0"/>
+          </a:xfrm>
+        </p:spPr>
+        <p:txBody>
+          <a:bodyPr/>
+          <a:lstStyle/>
+          <a:p/>
+          <a:p>
+            <a:pPr algn="l">
+              <a:spcAft>
+                <a:spcPts val="1400"/>
+              </a:spcAft>
+            </a:pPr>
+            <a:r>
+              <a:rPr sz="2600">
+                <a:solidFill>
+                  <a:srgbClr val="000000"/>
+                </a:solidFill>
+                <a:latin typeface="Calibri"/>
+              </a:rPr>
+              <a:t/>
+            </a:r>
+            <a:r>
+              <a:rPr b="1" sz="2600">
+                <a:solidFill>
+                  <a:srgbClr val="000000"/>
+                </a:solidFill>
+                <a:latin typeface="Calibri"/>
+              </a:rPr>
+              <a:t>Conclusion</a:t>
+            </a:r>
+            <a:r>
+              <a:rPr sz="2600">
+                <a:solidFill>
+                  <a:srgbClr val="000000"/>
+                </a:solidFill>
+                <a:latin typeface="Calibri"/>
+              </a:rPr>
+              <a:t>: Fusing character grounding with semantic layout awareness is essential for mitigating hallucinations in mission-critical AI.</a:t>
+            </a:r>
+          </a:p>
+          <a:p>
+            <a:pPr algn="l">
+              <a:spcAft>
+                <a:spcPts val="1400"/>
+              </a:spcAft>
+            </a:pPr>
+            <a:r>
+              <a:rPr sz="2600">
+                <a:solidFill>
+                  <a:srgbClr val="000000"/>
+                </a:solidFill>
+                <a:latin typeface="Calibri"/>
+              </a:rPr>
+              <a:t/>
+            </a:r>
+            <a:r>
+              <a:rPr b="1" sz="2600">
+                <a:solidFill>
+                  <a:srgbClr val="000000"/>
+                </a:solidFill>
+                <a:latin typeface="Calibri"/>
+              </a:rPr>
+              <a:t>Future Work</a:t>
+            </a:r>
+            <a:r>
+              <a:rPr sz="2600">
+                <a:solidFill>
+                  <a:srgbClr val="000000"/>
+                </a:solidFill>
+                <a:latin typeface="Calibri"/>
+              </a:rPr>
+              <a:t>: Scaling across dense tabular corpora and Investigating natively layout-aware architectures (LayoutLMv3).</a:t>
+            </a:r>
+          </a:p>
+        </p:txBody>
+      </p:sp>
+      <p:sp>
+        <p:nvSpPr>
+          <p:cNvPr id="4" name="Octagon 3"/>
+          <p:cNvSpPr/>
+          <p:nvPr/>
+        </p:nvSpPr>
+        <p:spPr>
+          <a:xfrm>
+            <a:off x="0" y="6766560"/>
+            <a:ext cx="11378915" cy="91440"/>
+          </a:xfrm>
+          <a:prstGeom prst="octagon">
+            <a:avLst/>
+          </a:prstGeom>
+          <a:solidFill>
+            <a:srgbClr val="003366"/>
+          </a:solidFill>
+          <a:ln>
+            <a:noFill/>
+          </a:ln>
+        </p:spPr>
+        <p:style>
+          <a:lnRef idx="1">
+            <a:schemeClr val="accent1"/>
+          </a:lnRef>
+          <a:fillRef idx="3">
+            <a:schemeClr val="accent1"/>
+          </a:fillRef>
+          <a:effectRef idx="2">
+            <a:schemeClr val="accent1"/>
+          </a:effectRef>
+          <a:fontRef idx="minor">
+            <a:schemeClr val="lt1"/>
+          </a:fontRef>
+        </p:style>
+        <p:txBody>
+          <a:bodyPr rtlCol="0" anchor="ctr"/>
+          <a:lstStyle/>
+          <a:p>
+            <a:pPr algn="ctr"/>
+          </a:p>
+        </p:txBody>
+      </p:sp>
+      <p:sp>
+        <p:nvSpPr>
+          <p:cNvPr id="5" name="TextBox 4"/>
+          <p:cNvSpPr txBox="1"/>
+          <p:nvPr/>
+        </p:nvSpPr>
+        <p:spPr>
+          <a:xfrm>
+            <a:off x="11430000" y="6400800"/>
+            <a:ext cx="731520" cy="365760"/>
+          </a:xfrm>
+          <a:prstGeom prst="rect">
+            <a:avLst/>
+          </a:prstGeom>
+          <a:noFill/>
+        </p:spPr>
+        <p:txBody>
+          <a:bodyPr wrap="none">
+            <a:spAutoFit/>
+          </a:bodyPr>
+          <a:lstStyle/>
+          <a:p>
+            <a:pPr algn="r">
+              <a:defRPr sz="1000">
+                <a:solidFill>
+                  <a:srgbClr val="003366"/>
+                </a:solidFill>
+              </a:defRPr>
+            </a:pPr>
+            <a:r>
+              <a:t>14 / 15</a:t>
+            </a:r>
+          </a:p>
+        </p:txBody>
+      </p:sp>
+    </p:spTree>
+  </p:cSld>
+  <p:clrMapOvr>
+    <a:masterClrMapping/>
+  </p:clrMapOvr>
+</p:sld>
+</file>
+
+<file path=ppt/slides/slide16.xml><?xml version="1.0" encoding="utf-8"?>
+<p:sld xmlns:a="http://schemas.openxmlformats.org/drawingml/2006/main" xmlns:p="http://schemas.openxmlformats.org/presentationml/2006/main" xmlns:r="http://schemas.openxmlformats.org/officeDocument/2006/relationships">
+  <p:cSld>
+    <p:spTree>
+      <p:nvGrpSpPr>
+        <p:cNvPr id="1" name=""/>
+        <p:cNvGrpSpPr/>
+        <p:nvPr/>
+      </p:nvGrpSpPr>
+      <p:grpSpPr/>
+      <p:sp>
+        <p:nvSpPr>
+          <p:cNvPr id="2" name="Title 1"/>
+          <p:cNvSpPr>
+            <a:spLocks noGrp="1"/>
+          </p:cNvSpPr>
+          <p:nvPr>
+            <p:ph type="title"/>
+          </p:nvPr>
+        </p:nvSpPr>
+        <p:spPr/>
+        <p:txBody>
+          <a:bodyPr/>
+          <a:lstStyle/>
+          <a:p>
+            <a:pPr algn="ctr">
+              <a:defRPr sz="3200" b="1">
+                <a:solidFill>
+                  <a:srgbClr val="003366"/>
+                </a:solidFill>
+              </a:defRPr>
+            </a:pPr>
+            <a:r>
+              <a:t>Thank You</a:t>
+            </a:r>
+          </a:p>
+        </p:txBody>
+      </p:sp>
+      <p:sp>
+        <p:nvSpPr>
+          <p:cNvPr id="3" name="Content Placeholder 2"/>
+          <p:cNvSpPr>
+            <a:spLocks noGrp="1"/>
+          </p:cNvSpPr>
+          <p:nvPr>
+            <p:ph idx="1"/>
+          </p:nvPr>
+        </p:nvSpPr>
+        <p:spPr>
+          <a:xfrm>
+            <a:off x="822960" y="1645920"/>
+            <a:ext cx="10515600" cy="0"/>
+          </a:xfrm>
+        </p:spPr>
+        <p:txBody>
+          <a:bodyPr/>
+          <a:lstStyle/>
+          <a:p/>
+        </p:txBody>
+      </p:sp>
+      <p:sp>
+        <p:nvSpPr>
+          <p:cNvPr id="4" name="Octagon 3"/>
+          <p:cNvSpPr/>
+          <p:nvPr/>
+        </p:nvSpPr>
+        <p:spPr>
+          <a:xfrm>
+            <a:off x="0" y="6766560"/>
+            <a:ext cx="12191695" cy="91440"/>
+          </a:xfrm>
+          <a:prstGeom prst="octagon">
+            <a:avLst/>
+          </a:prstGeom>
+          <a:solidFill>
+            <a:srgbClr val="003366"/>
+          </a:solidFill>
+          <a:ln>
+            <a:noFill/>
+          </a:ln>
+        </p:spPr>
+        <p:style>
+          <a:lnRef idx="1">
+            <a:schemeClr val="accent1"/>
+          </a:lnRef>
+          <a:fillRef idx="3">
+            <a:schemeClr val="accent1"/>
+          </a:fillRef>
+          <a:effectRef idx="2">
+            <a:schemeClr val="accent1"/>
+          </a:effectRef>
+          <a:fontRef idx="minor">
+            <a:schemeClr val="lt1"/>
+          </a:fontRef>
+        </p:style>
+        <p:txBody>
+          <a:bodyPr rtlCol="0" anchor="ctr"/>
+          <a:lstStyle/>
+          <a:p>
+            <a:pPr algn="ctr"/>
+          </a:p>
+        </p:txBody>
+      </p:sp>
+      <p:sp>
+        <p:nvSpPr>
+          <p:cNvPr id="5" name="TextBox 4"/>
+          <p:cNvSpPr txBox="1"/>
+          <p:nvPr/>
+        </p:nvSpPr>
+        <p:spPr>
+          <a:xfrm>
+            <a:off x="11430000" y="6400800"/>
+            <a:ext cx="731520" cy="365760"/>
+          </a:xfrm>
+          <a:prstGeom prst="rect">
+            <a:avLst/>
+          </a:prstGeom>
+          <a:noFill/>
+        </p:spPr>
+        <p:txBody>
+          <a:bodyPr wrap="none">
+            <a:spAutoFit/>
+          </a:bodyPr>
+          <a:lstStyle/>
+          <a:p>
+            <a:pPr algn="r">
+              <a:defRPr sz="1000">
+                <a:solidFill>
+                  <a:srgbClr val="003366"/>
+                </a:solidFill>
+              </a:defRPr>
+            </a:pPr>
+            <a:r>
+              <a:t>15 / 15</a:t>
             </a:r>
           </a:p>
         </p:txBody>
@@ -3736,7 +4545,7 @@
           <a:lstStyle/>
           <a:p>
             <a:pPr algn="ctr">
-              <a:defRPr sz="3600" b="1">
+              <a:defRPr sz="3200" b="1">
                 <a:solidFill>
                   <a:srgbClr val="003366"/>
                 </a:solidFill>
@@ -3760,8 +4569,8 @@
         </p:nvSpPr>
         <p:spPr>
           <a:xfrm>
-            <a:off x="548640" y="1645920"/>
-            <a:ext cx="10972800" cy="0"/>
+            <a:off x="822960" y="1645920"/>
+            <a:ext cx="10515600" cy="0"/>
           </a:xfrm>
         </p:spPr>
         <p:txBody>
@@ -3769,13 +4578,13 @@
           <a:lstStyle/>
           <a:p/>
           <a:p>
-            <a:pPr>
+            <a:pPr algn="l">
               <a:spcAft>
-                <a:spcPts val="1200"/>
+                <a:spcPts val="1400"/>
               </a:spcAft>
             </a:pPr>
             <a:r>
-              <a:rPr sz="2400">
+              <a:rPr sz="2600">
                 <a:solidFill>
                   <a:srgbClr val="000000"/>
                 </a:solidFill>
@@ -3784,7 +4593,7 @@
               <a:t/>
             </a:r>
             <a:r>
-              <a:rPr b="1" sz="2400">
+              <a:rPr b="1" sz="2600">
                 <a:solidFill>
                   <a:srgbClr val="000000"/>
                 </a:solidFill>
@@ -3793,7 +4602,7 @@
               <a:t>The Challenge</a:t>
             </a:r>
             <a:r>
-              <a:rPr sz="2400">
+              <a:rPr sz="2600">
                 <a:solidFill>
                   <a:srgbClr val="000000"/>
                 </a:solidFill>
@@ -3803,13 +4612,13 @@
             </a:r>
           </a:p>
           <a:p>
-            <a:pPr>
+            <a:pPr algn="l">
               <a:spcAft>
-                <a:spcPts val="1200"/>
+                <a:spcPts val="1400"/>
               </a:spcAft>
             </a:pPr>
             <a:r>
-              <a:rPr sz="2400">
+              <a:rPr sz="2600">
                 <a:solidFill>
                   <a:srgbClr val="000000"/>
                 </a:solidFill>
@@ -3818,7 +4627,7 @@
               <a:t/>
             </a:r>
             <a:r>
-              <a:rPr b="1" sz="2400">
+              <a:rPr b="1" sz="2600">
                 <a:solidFill>
                   <a:srgbClr val="000000"/>
                 </a:solidFill>
@@ -3827,23 +4636,23 @@
               <a:t>The Bottleneck</a:t>
             </a:r>
             <a:r>
-              <a:rPr sz="2400">
-                <a:solidFill>
-                  <a:srgbClr val="000000"/>
-                </a:solidFill>
-                <a:latin typeface="Calibri"/>
-              </a:rPr>
-              <a:t>: Standalone Large Language Models (LLMs) are linguistically robust but lack spatial awareness of document geometries.</a:t>
-            </a:r>
-          </a:p>
-          <a:p>
-            <a:pPr>
+              <a:rPr sz="2600">
+                <a:solidFill>
+                  <a:srgbClr val="000000"/>
+                </a:solidFill>
+                <a:latin typeface="Calibri"/>
+              </a:rPr>
+              <a:t>: Standalone Large Language Models (LLMs) are linguistically robust but lack spatial awareness.</a:t>
+            </a:r>
+          </a:p>
+          <a:p>
+            <a:pPr algn="l">
               <a:spcAft>
-                <a:spcPts val="1200"/>
+                <a:spcPts val="1400"/>
               </a:spcAft>
             </a:pPr>
             <a:r>
-              <a:rPr sz="2400">
+              <a:rPr sz="2600">
                 <a:solidFill>
                   <a:srgbClr val="000000"/>
                 </a:solidFill>
@@ -3852,7 +4661,7 @@
               <a:t/>
             </a:r>
             <a:r>
-              <a:rPr b="1" sz="2400">
+              <a:rPr b="1" sz="2600">
                 <a:solidFill>
                   <a:srgbClr val="000000"/>
                 </a:solidFill>
@@ -3861,23 +4670,23 @@
               <a:t>The Perception-Cognition Gap</a:t>
             </a:r>
             <a:r>
-              <a:rPr sz="2400">
-                <a:solidFill>
-                  <a:srgbClr val="000000"/>
-                </a:solidFill>
-                <a:latin typeface="Calibri"/>
-              </a:rPr>
-              <a:t>: A fundamental disconnect between a model's reasoning capacity and its ability to "see" fine-grained textual evidence.</a:t>
-            </a:r>
-          </a:p>
-          <a:p>
-            <a:pPr>
+              <a:rPr sz="2600">
+                <a:solidFill>
+                  <a:srgbClr val="000000"/>
+                </a:solidFill>
+                <a:latin typeface="Calibri"/>
+              </a:rPr>
+              <a:t>: A disconnect between a model's reasoning and its ability to "see" fine-grained textual evidence.</a:t>
+            </a:r>
+          </a:p>
+          <a:p>
+            <a:pPr algn="l">
               <a:spcAft>
-                <a:spcPts val="1200"/>
+                <a:spcPts val="1400"/>
               </a:spcAft>
             </a:pPr>
             <a:r>
-              <a:rPr sz="2400">
+              <a:rPr sz="2600">
                 <a:solidFill>
                   <a:srgbClr val="000000"/>
                 </a:solidFill>
@@ -3886,7 +4695,7 @@
               <a:t/>
             </a:r>
             <a:r>
-              <a:rPr b="1" sz="2400">
+              <a:rPr b="1" sz="2600">
                 <a:solidFill>
                   <a:srgbClr val="000000"/>
                 </a:solidFill>
@@ -3895,20 +4704,63 @@
               <a:t>The Cost of Failure</a:t>
             </a:r>
             <a:r>
-              <a:rPr sz="2400">
-                <a:solidFill>
-                  <a:srgbClr val="000000"/>
-                </a:solidFill>
-                <a:latin typeface="Calibri"/>
-              </a:rPr>
-              <a:t>: Hallucination-related errors and structural data corruption in automated pipelines.</a:t>
-            </a:r>
-          </a:p>
-        </p:txBody>
-      </p:sp>
-      <p:sp>
-        <p:nvSpPr>
-          <p:cNvPr id="4" name="TextBox 3"/>
+              <a:rPr sz="2600">
+                <a:solidFill>
+                  <a:srgbClr val="000000"/>
+                </a:solidFill>
+                <a:latin typeface="Calibri"/>
+              </a:rPr>
+              <a:t>: Hallucination-related errors in automated pipelines.</a:t>
+            </a:r>
+          </a:p>
+        </p:txBody>
+      </p:sp>
+      <p:sp>
+        <p:nvSpPr>
+          <p:cNvPr id="4" name="Octagon 3"/>
+          <p:cNvSpPr/>
+          <p:nvPr/>
+        </p:nvSpPr>
+        <p:spPr>
+          <a:xfrm>
+            <a:off x="0" y="6766560"/>
+            <a:ext cx="812779" cy="91440"/>
+          </a:xfrm>
+          <a:prstGeom prst="octagon">
+            <a:avLst/>
+          </a:prstGeom>
+          <a:solidFill>
+            <a:srgbClr val="003366"/>
+          </a:solidFill>
+          <a:ln>
+            <a:noFill/>
+          </a:ln>
+        </p:spPr>
+        <p:style>
+          <a:lnRef idx="1">
+            <a:schemeClr val="accent1"/>
+          </a:lnRef>
+          <a:fillRef idx="3">
+            <a:schemeClr val="accent1"/>
+          </a:fillRef>
+          <a:effectRef idx="2">
+            <a:schemeClr val="accent1"/>
+          </a:effectRef>
+          <a:fontRef idx="minor">
+            <a:schemeClr val="lt1"/>
+          </a:fontRef>
+        </p:style>
+        <p:txBody>
+          <a:bodyPr rtlCol="0" anchor="ctr"/>
+          <a:lstStyle/>
+          <a:p>
+            <a:pPr algn="ctr"/>
+          </a:p>
+        </p:txBody>
+      </p:sp>
+      <p:sp>
+        <p:nvSpPr>
+          <p:cNvPr id="5" name="TextBox 4"/>
           <p:cNvSpPr txBox="1"/>
           <p:nvPr/>
         </p:nvSpPr>
@@ -3929,14 +4781,14 @@
           <a:lstStyle/>
           <a:p>
             <a:pPr algn="r">
-              <a:defRPr sz="1200">
+              <a:defRPr sz="1000">
                 <a:solidFill>
                   <a:srgbClr val="003366"/>
                 </a:solidFill>
               </a:defRPr>
             </a:pPr>
             <a:r>
-              <a:t>1 / 11</a:t>
+              <a:t>1 / 15</a:t>
             </a:r>
           </a:p>
         </p:txBody>
@@ -3975,7 +4827,7 @@
           <a:lstStyle/>
           <a:p>
             <a:pPr algn="ctr">
-              <a:defRPr sz="3600" b="1">
+              <a:defRPr sz="3200" b="1">
                 <a:solidFill>
                   <a:srgbClr val="003366"/>
                 </a:solidFill>
@@ -3999,8 +4851,8 @@
         </p:nvSpPr>
         <p:spPr>
           <a:xfrm>
-            <a:off x="548640" y="1645920"/>
-            <a:ext cx="10972800" cy="0"/>
+            <a:off x="822960" y="1645920"/>
+            <a:ext cx="10515600" cy="0"/>
           </a:xfrm>
         </p:spPr>
         <p:txBody>
@@ -4008,13 +4860,13 @@
           <a:lstStyle/>
           <a:p/>
           <a:p>
-            <a:pPr>
+            <a:pPr algn="l">
               <a:spcAft>
-                <a:spcPts val="1200"/>
+                <a:spcPts val="1400"/>
               </a:spcAft>
             </a:pPr>
             <a:r>
-              <a:rPr sz="2400">
+              <a:rPr sz="2600">
                 <a:solidFill>
                   <a:srgbClr val="000000"/>
                 </a:solidFill>
@@ -4023,7 +4875,7 @@
               <a:t/>
             </a:r>
             <a:r>
-              <a:rPr b="1" sz="2400">
+              <a:rPr b="1" sz="2600">
                 <a:solidFill>
                   <a:srgbClr val="000000"/>
                 </a:solidFill>
@@ -4032,7 +4884,7 @@
               <a:t>Traditional OCR (Tesseract)</a:t>
             </a:r>
             <a:r>
-              <a:rPr sz="2400">
+              <a:rPr sz="2600">
                 <a:solidFill>
                   <a:srgbClr val="000000"/>
                 </a:solidFill>
@@ -4041,7 +4893,7 @@
               <a:t>: Preserves literal characters but linearizes text horizontally, causing </a:t>
             </a:r>
             <a:r>
-              <a:rPr b="1" sz="2400">
+              <a:rPr b="1" sz="2600">
                 <a:solidFill>
                   <a:srgbClr val="000000"/>
                 </a:solidFill>
@@ -4050,23 +4902,23 @@
               <a:t>Structural Fragmentation</a:t>
             </a:r>
             <a:r>
-              <a:rPr sz="2400">
-                <a:solidFill>
-                  <a:srgbClr val="000000"/>
-                </a:solidFill>
-                <a:latin typeface="Calibri"/>
-              </a:rPr>
-              <a:t> in multi-column layouts.</a:t>
-            </a:r>
-          </a:p>
-          <a:p>
-            <a:pPr>
+              <a:rPr sz="2600">
+                <a:solidFill>
+                  <a:srgbClr val="000000"/>
+                </a:solidFill>
+                <a:latin typeface="Calibri"/>
+              </a:rPr>
+              <a:t>.</a:t>
+            </a:r>
+          </a:p>
+          <a:p>
+            <a:pPr algn="l">
               <a:spcAft>
-                <a:spcPts val="1200"/>
+                <a:spcPts val="1400"/>
               </a:spcAft>
             </a:pPr>
             <a:r>
-              <a:rPr sz="2400">
+              <a:rPr sz="2600">
                 <a:solidFill>
                   <a:srgbClr val="000000"/>
                 </a:solidFill>
@@ -4075,7 +4927,7 @@
               <a:t/>
             </a:r>
             <a:r>
-              <a:rPr b="1" sz="2400">
+              <a:rPr b="1" sz="2600">
                 <a:solidFill>
                   <a:srgbClr val="000000"/>
                 </a:solidFill>
@@ -4084,7 +4936,7 @@
               <a:t>Standalone VLMs (Gemini, LLaVA)</a:t>
             </a:r>
             <a:r>
-              <a:rPr sz="2400">
+              <a:rPr sz="2600">
                 <a:solidFill>
                   <a:srgbClr val="000000"/>
                 </a:solidFill>
@@ -4093,7 +4945,7 @@
               <a:t>: Elegant multimodal perception but limited by </a:t>
             </a:r>
             <a:r>
-              <a:rPr b="1" sz="2400">
+              <a:rPr b="1" sz="2600">
                 <a:solidFill>
                   <a:srgbClr val="000000"/>
                 </a:solidFill>
@@ -4102,23 +4954,23 @@
               <a:t>Resolution-Loss Hallucination</a:t>
             </a:r>
             <a:r>
-              <a:rPr sz="2400">
-                <a:solidFill>
-                  <a:srgbClr val="000000"/>
-                </a:solidFill>
-                <a:latin typeface="Calibri"/>
-              </a:rPr>
-              <a:t> in dense tabular regions.</a:t>
-            </a:r>
-          </a:p>
-          <a:p>
-            <a:pPr>
+              <a:rPr sz="2600">
+                <a:solidFill>
+                  <a:srgbClr val="000000"/>
+                </a:solidFill>
+                <a:latin typeface="Calibri"/>
+              </a:rPr>
+              <a:t>.</a:t>
+            </a:r>
+          </a:p>
+          <a:p>
+            <a:pPr algn="l">
               <a:spcAft>
-                <a:spcPts val="1200"/>
+                <a:spcPts val="1400"/>
               </a:spcAft>
             </a:pPr>
             <a:r>
-              <a:rPr sz="2400">
+              <a:rPr sz="2600">
                 <a:solidFill>
                   <a:srgbClr val="000000"/>
                 </a:solidFill>
@@ -4127,7 +4979,7 @@
               <a:t/>
             </a:r>
             <a:r>
-              <a:rPr b="1" sz="2400">
+              <a:rPr b="1" sz="2600">
                 <a:solidFill>
                   <a:srgbClr val="000000"/>
                 </a:solidFill>
@@ -4136,20 +4988,63 @@
               <a:t>The Missing Link</a:t>
             </a:r>
             <a:r>
-              <a:rPr sz="2400">
-                <a:solidFill>
-                  <a:srgbClr val="000000"/>
-                </a:solidFill>
-                <a:latin typeface="Calibri"/>
-              </a:rPr>
-              <a:t>: A lack of rigorous, systems-level benchmarking that evaluates the reliability trade-offs between deterministic parsing and semantic layout mapping.</a:t>
-            </a:r>
-          </a:p>
-        </p:txBody>
-      </p:sp>
-      <p:sp>
-        <p:nvSpPr>
-          <p:cNvPr id="4" name="TextBox 3"/>
+              <a:rPr sz="2600">
+                <a:solidFill>
+                  <a:srgbClr val="000000"/>
+                </a:solidFill>
+                <a:latin typeface="Calibri"/>
+              </a:rPr>
+              <a:t>: Lack of benchmarking evaluating the trade-offs between deterministic parsing and semantic layout mapping.</a:t>
+            </a:r>
+          </a:p>
+        </p:txBody>
+      </p:sp>
+      <p:sp>
+        <p:nvSpPr>
+          <p:cNvPr id="4" name="Octagon 3"/>
+          <p:cNvSpPr/>
+          <p:nvPr/>
+        </p:nvSpPr>
+        <p:spPr>
+          <a:xfrm>
+            <a:off x="0" y="6766560"/>
+            <a:ext cx="1625559" cy="91440"/>
+          </a:xfrm>
+          <a:prstGeom prst="octagon">
+            <a:avLst/>
+          </a:prstGeom>
+          <a:solidFill>
+            <a:srgbClr val="003366"/>
+          </a:solidFill>
+          <a:ln>
+            <a:noFill/>
+          </a:ln>
+        </p:spPr>
+        <p:style>
+          <a:lnRef idx="1">
+            <a:schemeClr val="accent1"/>
+          </a:lnRef>
+          <a:fillRef idx="3">
+            <a:schemeClr val="accent1"/>
+          </a:fillRef>
+          <a:effectRef idx="2">
+            <a:schemeClr val="accent1"/>
+          </a:effectRef>
+          <a:fontRef idx="minor">
+            <a:schemeClr val="lt1"/>
+          </a:fontRef>
+        </p:style>
+        <p:txBody>
+          <a:bodyPr rtlCol="0" anchor="ctr"/>
+          <a:lstStyle/>
+          <a:p>
+            <a:pPr algn="ctr"/>
+          </a:p>
+        </p:txBody>
+      </p:sp>
+      <p:sp>
+        <p:nvSpPr>
+          <p:cNvPr id="5" name="TextBox 4"/>
           <p:cNvSpPr txBox="1"/>
           <p:nvPr/>
         </p:nvSpPr>
@@ -4170,14 +5065,14 @@
           <a:lstStyle/>
           <a:p>
             <a:pPr algn="r">
-              <a:defRPr sz="1200">
+              <a:defRPr sz="1000">
                 <a:solidFill>
                   <a:srgbClr val="003366"/>
                 </a:solidFill>
               </a:defRPr>
             </a:pPr>
             <a:r>
-              <a:t>2 / 11</a:t>
+              <a:t>2 / 15</a:t>
             </a:r>
           </a:p>
         </p:txBody>
@@ -4216,7 +5111,7 @@
           <a:lstStyle/>
           <a:p>
             <a:pPr algn="ctr">
-              <a:defRPr sz="3600" b="1">
+              <a:defRPr sz="3200" b="1">
                 <a:solidFill>
                   <a:srgbClr val="003366"/>
                 </a:solidFill>
@@ -4240,8 +5135,8 @@
         </p:nvSpPr>
         <p:spPr>
           <a:xfrm>
-            <a:off x="548640" y="1645920"/>
-            <a:ext cx="10972800" cy="0"/>
+            <a:off x="822960" y="1645920"/>
+            <a:ext cx="10515600" cy="0"/>
           </a:xfrm>
         </p:spPr>
         <p:txBody>
@@ -4249,13 +5144,13 @@
           <a:lstStyle/>
           <a:p/>
           <a:p>
-            <a:pPr>
+            <a:pPr algn="l">
               <a:spcAft>
-                <a:spcPts val="1200"/>
+                <a:spcPts val="1400"/>
               </a:spcAft>
             </a:pPr>
             <a:r>
-              <a:rPr sz="2400">
+              <a:rPr sz="2600">
                 <a:solidFill>
                   <a:srgbClr val="000000"/>
                 </a:solidFill>
@@ -4264,7 +5159,7 @@
               <a:t/>
             </a:r>
             <a:r>
-              <a:rPr b="1" sz="2400">
+              <a:rPr b="1" sz="2600">
                 <a:solidFill>
                   <a:srgbClr val="000000"/>
                 </a:solidFill>
@@ -4273,7 +5168,7 @@
               <a:t>Core Strategy</a:t>
             </a:r>
             <a:r>
-              <a:rPr sz="2400">
+              <a:rPr sz="2600">
                 <a:solidFill>
                   <a:srgbClr val="000000"/>
                 </a:solidFill>
@@ -4283,13 +5178,13 @@
             </a:r>
           </a:p>
           <a:p>
-            <a:pPr>
+            <a:pPr algn="l">
               <a:spcAft>
-                <a:spcPts val="1200"/>
+                <a:spcPts val="1400"/>
               </a:spcAft>
             </a:pPr>
             <a:r>
-              <a:rPr sz="2400">
+              <a:rPr sz="2600">
                 <a:solidFill>
                   <a:srgbClr val="000000"/>
                 </a:solidFill>
@@ -4298,7 +5193,7 @@
               <a:t/>
             </a:r>
             <a:r>
-              <a:rPr b="1" sz="2400">
+              <a:rPr b="1" sz="2600">
                 <a:solidFill>
                   <a:srgbClr val="000000"/>
                 </a:solidFill>
@@ -4307,23 +5202,23 @@
               <a:t>Stream 1 (Deterministic)</a:t>
             </a:r>
             <a:r>
-              <a:rPr sz="2400">
-                <a:solidFill>
-                  <a:srgbClr val="000000"/>
-                </a:solidFill>
-                <a:latin typeface="Calibri"/>
-              </a:rPr>
-              <a:t>: PaddleOCR for high-precision character and bounding-box detection.</a:t>
-            </a:r>
-          </a:p>
-          <a:p>
-            <a:pPr>
+              <a:rPr sz="2600">
+                <a:solidFill>
+                  <a:srgbClr val="000000"/>
+                </a:solidFill>
+                <a:latin typeface="Calibri"/>
+              </a:rPr>
+              <a:t>: PaddleOCR for high-precision character detection.</a:t>
+            </a:r>
+          </a:p>
+          <a:p>
+            <a:pPr algn="l">
               <a:spcAft>
-                <a:spcPts val="1200"/>
+                <a:spcPts val="1400"/>
               </a:spcAft>
             </a:pPr>
             <a:r>
-              <a:rPr sz="2400">
+              <a:rPr sz="2600">
                 <a:solidFill>
                   <a:srgbClr val="000000"/>
                 </a:solidFill>
@@ -4332,7 +5227,7 @@
               <a:t/>
             </a:r>
             <a:r>
-              <a:rPr b="1" sz="2400">
+              <a:rPr b="1" sz="2600">
                 <a:solidFill>
                   <a:srgbClr val="000000"/>
                 </a:solidFill>
@@ -4341,23 +5236,23 @@
               <a:t>Stream 2 (Semantic)</a:t>
             </a:r>
             <a:r>
-              <a:rPr sz="2400">
-                <a:solidFill>
-                  <a:srgbClr val="000000"/>
-                </a:solidFill>
-                <a:latin typeface="Calibri"/>
-              </a:rPr>
-              <a:t>: Vision-Language Model for visual layout summarization and structural context.</a:t>
-            </a:r>
-          </a:p>
-          <a:p>
-            <a:pPr>
+              <a:rPr sz="2600">
+                <a:solidFill>
+                  <a:srgbClr val="000000"/>
+                </a:solidFill>
+                <a:latin typeface="Calibri"/>
+              </a:rPr>
+              <a:t>: Vision-Language Model for layout context.</a:t>
+            </a:r>
+          </a:p>
+          <a:p>
+            <a:pPr algn="l">
               <a:spcAft>
-                <a:spcPts val="1200"/>
+                <a:spcPts val="1400"/>
               </a:spcAft>
             </a:pPr>
             <a:r>
-              <a:rPr sz="2400">
+              <a:rPr sz="2600">
                 <a:solidFill>
                   <a:srgbClr val="000000"/>
                 </a:solidFill>
@@ -4366,7 +5261,7 @@
               <a:t/>
             </a:r>
             <a:r>
-              <a:rPr b="1" sz="2400">
+              <a:rPr b="1" sz="2600">
                 <a:solidFill>
                   <a:srgbClr val="000000"/>
                 </a:solidFill>
@@ -4375,20 +5270,63 @@
               <a:t>Grounding Reliability</a:t>
             </a:r>
             <a:r>
-              <a:rPr sz="2400">
-                <a:solidFill>
-                  <a:srgbClr val="000000"/>
-                </a:solidFill>
-                <a:latin typeface="Calibri"/>
-              </a:rPr>
-              <a:t>: Grounding the generative visual summary in the deterministic OCR character sequence to suppress resolution-loss errors.</a:t>
-            </a:r>
-          </a:p>
-        </p:txBody>
-      </p:sp>
-      <p:sp>
-        <p:nvSpPr>
-          <p:cNvPr id="4" name="TextBox 3"/>
+              <a:rPr sz="2600">
+                <a:solidFill>
+                  <a:srgbClr val="000000"/>
+                </a:solidFill>
+                <a:latin typeface="Calibri"/>
+              </a:rPr>
+              <a:t>: Grounding visual summaries in OCR character sequences to suppress resolution-loss errors.</a:t>
+            </a:r>
+          </a:p>
+        </p:txBody>
+      </p:sp>
+      <p:sp>
+        <p:nvSpPr>
+          <p:cNvPr id="4" name="Octagon 3"/>
+          <p:cNvSpPr/>
+          <p:nvPr/>
+        </p:nvSpPr>
+        <p:spPr>
+          <a:xfrm>
+            <a:off x="0" y="6766560"/>
+            <a:ext cx="2438339" cy="91440"/>
+          </a:xfrm>
+          <a:prstGeom prst="octagon">
+            <a:avLst/>
+          </a:prstGeom>
+          <a:solidFill>
+            <a:srgbClr val="003366"/>
+          </a:solidFill>
+          <a:ln>
+            <a:noFill/>
+          </a:ln>
+        </p:spPr>
+        <p:style>
+          <a:lnRef idx="1">
+            <a:schemeClr val="accent1"/>
+          </a:lnRef>
+          <a:fillRef idx="3">
+            <a:schemeClr val="accent1"/>
+          </a:fillRef>
+          <a:effectRef idx="2">
+            <a:schemeClr val="accent1"/>
+          </a:effectRef>
+          <a:fontRef idx="minor">
+            <a:schemeClr val="lt1"/>
+          </a:fontRef>
+        </p:style>
+        <p:txBody>
+          <a:bodyPr rtlCol="0" anchor="ctr"/>
+          <a:lstStyle/>
+          <a:p>
+            <a:pPr algn="ctr"/>
+          </a:p>
+        </p:txBody>
+      </p:sp>
+      <p:sp>
+        <p:nvSpPr>
+          <p:cNvPr id="5" name="TextBox 4"/>
           <p:cNvSpPr txBox="1"/>
           <p:nvPr/>
         </p:nvSpPr>
@@ -4409,14 +5347,14 @@
           <a:lstStyle/>
           <a:p>
             <a:pPr algn="r">
-              <a:defRPr sz="1200">
+              <a:defRPr sz="1000">
                 <a:solidFill>
                   <a:srgbClr val="003366"/>
                 </a:solidFill>
               </a:defRPr>
             </a:pPr>
             <a:r>
-              <a:t>3 / 11</a:t>
+              <a:t>3 / 15</a:t>
             </a:r>
           </a:p>
         </p:txBody>
@@ -4455,7 +5393,7 @@
           <a:lstStyle/>
           <a:p>
             <a:pPr algn="ctr">
-              <a:defRPr sz="3600" b="1">
+              <a:defRPr sz="3200" b="1">
                 <a:solidFill>
                   <a:srgbClr val="003366"/>
                 </a:solidFill>
@@ -4477,89 +5415,59 @@
             <p:ph idx="1"/>
           </p:nvPr>
         </p:nvSpPr>
-        <p:spPr>
-          <a:xfrm>
-            <a:off x="457200" y="1645920"/>
-            <a:ext cx="5943600" cy="0"/>
-          </a:xfrm>
-        </p:spPr>
+        <p:spPr/>
         <p:txBody>
           <a:bodyPr/>
           <a:lstStyle/>
           <a:p/>
-          <a:p>
-            <a:pPr>
-              <a:spcAft>
-                <a:spcPts val="1200"/>
-              </a:spcAft>
-            </a:pPr>
-            <a:r>
-              <a:rPr sz="2400">
-                <a:solidFill>
-                  <a:srgbClr val="000000"/>
-                </a:solidFill>
-                <a:latin typeface="Calibri"/>
-              </a:rPr>
-              <a:t/>
-            </a:r>
-            <a:r>
-              <a:rPr b="1" sz="2400">
-                <a:solidFill>
-                  <a:srgbClr val="000000"/>
-                </a:solidFill>
-                <a:latin typeface="Calibri"/>
-              </a:rPr>
-              <a:t>Layout-Aware Retrieval</a:t>
-            </a:r>
-            <a:r>
-              <a:rPr sz="2400">
-                <a:solidFill>
-                  <a:srgbClr val="000000"/>
-                </a:solidFill>
-                <a:latin typeface="Calibri"/>
-              </a:rPr>
-              <a:t>: Fusing character tokens and spatial embeddings in a shared vector space (FAISS).</a:t>
-            </a:r>
-          </a:p>
-          <a:p>
-            <a:pPr>
-              <a:spcAft>
-                <a:spcPts val="1200"/>
-              </a:spcAft>
-            </a:pPr>
-            <a:r>
-              <a:rPr sz="2400">
-                <a:solidFill>
-                  <a:srgbClr val="000000"/>
-                </a:solidFill>
-                <a:latin typeface="Calibri"/>
-              </a:rPr>
-              <a:t/>
-            </a:r>
-            <a:r>
-              <a:rPr b="1" sz="2400">
-                <a:solidFill>
-                  <a:srgbClr val="000000"/>
-                </a:solidFill>
-                <a:latin typeface="Calibri"/>
-              </a:rPr>
-              <a:t>Zero-Shot Protocol</a:t>
-            </a:r>
-            <a:r>
-              <a:rPr sz="2400">
-                <a:solidFill>
-                  <a:srgbClr val="000000"/>
-                </a:solidFill>
-                <a:latin typeface="Calibri"/>
-              </a:rPr>
-              <a:t>: Evaluating out-of-the-box robustness without task-specific fine-tuning.</a:t>
-            </a:r>
-          </a:p>
-        </p:txBody>
-      </p:sp>
-      <p:sp>
-        <p:nvSpPr>
-          <p:cNvPr id="4" name="TextBox 3"/>
+        </p:txBody>
+      </p:sp>
+      <p:sp>
+        <p:nvSpPr>
+          <p:cNvPr id="4" name="Octagon 3"/>
+          <p:cNvSpPr/>
+          <p:nvPr/>
+        </p:nvSpPr>
+        <p:spPr>
+          <a:xfrm>
+            <a:off x="0" y="6766560"/>
+            <a:ext cx="3251118" cy="91440"/>
+          </a:xfrm>
+          <a:prstGeom prst="octagon">
+            <a:avLst/>
+          </a:prstGeom>
+          <a:solidFill>
+            <a:srgbClr val="003366"/>
+          </a:solidFill>
+          <a:ln>
+            <a:noFill/>
+          </a:ln>
+        </p:spPr>
+        <p:style>
+          <a:lnRef idx="1">
+            <a:schemeClr val="accent1"/>
+          </a:lnRef>
+          <a:fillRef idx="3">
+            <a:schemeClr val="accent1"/>
+          </a:fillRef>
+          <a:effectRef idx="2">
+            <a:schemeClr val="accent1"/>
+          </a:effectRef>
+          <a:fontRef idx="minor">
+            <a:schemeClr val="lt1"/>
+          </a:fontRef>
+        </p:style>
+        <p:txBody>
+          <a:bodyPr rtlCol="0" anchor="ctr"/>
+          <a:lstStyle/>
+          <a:p>
+            <a:pPr algn="ctr"/>
+          </a:p>
+        </p:txBody>
+      </p:sp>
+      <p:sp>
+        <p:nvSpPr>
+          <p:cNvPr id="5" name="TextBox 4"/>
           <p:cNvSpPr txBox="1"/>
           <p:nvPr/>
         </p:nvSpPr>
@@ -4580,21 +5488,21 @@
           <a:lstStyle/>
           <a:p>
             <a:pPr algn="r">
-              <a:defRPr sz="1200">
+              <a:defRPr sz="1000">
                 <a:solidFill>
                   <a:srgbClr val="003366"/>
                 </a:solidFill>
               </a:defRPr>
             </a:pPr>
             <a:r>
-              <a:t>4 / 11</a:t>
+              <a:t>4 / 15</a:t>
             </a:r>
           </a:p>
         </p:txBody>
       </p:sp>
       <p:pic>
         <p:nvPicPr>
-          <p:cNvPr id="5" name="Picture 4" descr="system_architecture.png"/>
+          <p:cNvPr id="6" name="Picture 5" descr="system_architecture.png"/>
           <p:cNvPicPr>
             <a:picLocks noChangeAspect="1"/>
           </p:cNvPicPr>
@@ -4608,8 +5516,8 @@
         </p:blipFill>
         <p:spPr>
           <a:xfrm>
-            <a:off x="6583680" y="1828800"/>
-            <a:ext cx="5029200" cy="12496800"/>
+            <a:off x="1386687" y="1645920"/>
+            <a:ext cx="9418320" cy="4572000"/>
           </a:xfrm>
           <a:prstGeom prst="rect">
             <a:avLst/>
@@ -4650,14 +5558,14 @@
           <a:lstStyle/>
           <a:p>
             <a:pPr algn="ctr">
-              <a:defRPr sz="3600" b="1">
+              <a:defRPr sz="3200" b="1">
                 <a:solidFill>
                   <a:srgbClr val="003366"/>
                 </a:solidFill>
               </a:defRPr>
             </a:pPr>
             <a:r>
-              <a:t>Mathematical Formalization of Reliability</a:t>
+              <a:t>Layout-Aware Retrieval Strategy</a:t>
             </a:r>
           </a:p>
         </p:txBody>
@@ -4674,8 +5582,8 @@
         </p:nvSpPr>
         <p:spPr>
           <a:xfrm>
-            <a:off x="457200" y="1645920"/>
-            <a:ext cx="0" cy="0"/>
+            <a:off x="822960" y="1645920"/>
+            <a:ext cx="10515600" cy="0"/>
           </a:xfrm>
         </p:spPr>
         <p:txBody>
@@ -4683,13 +5591,13 @@
           <a:lstStyle/>
           <a:p/>
           <a:p>
-            <a:pPr>
+            <a:pPr algn="l">
               <a:spcAft>
-                <a:spcPts val="1200"/>
+                <a:spcPts val="1400"/>
               </a:spcAft>
             </a:pPr>
             <a:r>
-              <a:rPr sz="2400">
+              <a:rPr sz="2600">
                 <a:solidFill>
                   <a:srgbClr val="000000"/>
                 </a:solidFill>
@@ -4698,32 +5606,32 @@
               <a:t/>
             </a:r>
             <a:r>
-              <a:rPr b="1" sz="2400">
-                <a:solidFill>
-                  <a:srgbClr val="000000"/>
-                </a:solidFill>
-                <a:latin typeface="Calibri"/>
-              </a:rPr>
-              <a:t>Hybrid Synchronization (1.1)</a:t>
-            </a:r>
-            <a:r>
-              <a:rPr sz="2400">
-                <a:solidFill>
-                  <a:srgbClr val="000000"/>
-                </a:solidFill>
-                <a:latin typeface="Calibri"/>
-              </a:rPr>
-              <a:t>: $C = S_{ocr} \parallel S_{vlm}$</a:t>
-            </a:r>
-          </a:p>
-          <a:p>
-            <a:pPr>
+              <a:rPr b="1" sz="2600">
+                <a:solidFill>
+                  <a:srgbClr val="000000"/>
+                </a:solidFill>
+                <a:latin typeface="Calibri"/>
+              </a:rPr>
+              <a:t>Dual-Stream Logic</a:t>
+            </a:r>
+            <a:r>
+              <a:rPr sz="2600">
+                <a:solidFill>
+                  <a:srgbClr val="000000"/>
+                </a:solidFill>
+                <a:latin typeface="Calibri"/>
+              </a:rPr>
+              <a:t>: Fusing character tokens and spatial embeddings in a shared vector space (FAISS).</a:t>
+            </a:r>
+          </a:p>
+          <a:p>
+            <a:pPr algn="l">
               <a:spcAft>
-                <a:spcPts val="1200"/>
+                <a:spcPts val="1400"/>
               </a:spcAft>
             </a:pPr>
             <a:r>
-              <a:rPr sz="2400">
+              <a:rPr sz="2600">
                 <a:solidFill>
                   <a:srgbClr val="000000"/>
                 </a:solidFill>
@@ -4732,131 +5640,72 @@
               <a:t/>
             </a:r>
             <a:r>
-              <a:rPr b="1" sz="2400">
-                <a:solidFill>
-                  <a:srgbClr val="000000"/>
-                </a:solidFill>
-                <a:latin typeface="Calibri"/>
-              </a:rPr>
-              <a:t>Accuracy Metric: ANLS (3.1)</a:t>
-            </a:r>
-            <a:r>
-              <a:rPr sz="2400">
-                <a:solidFill>
-                  <a:srgbClr val="000000"/>
-                </a:solidFill>
-                <a:latin typeface="Calibri"/>
-              </a:rPr>
-              <a:t>:</a:t>
-            </a:r>
-          </a:p>
-          <a:p>
-            <a:pPr>
-              <a:spcAft>
-                <a:spcPts val="1200"/>
-              </a:spcAft>
-            </a:pPr>
-            <a:r>
-              <a:rPr sz="2400">
-                <a:solidFill>
-                  <a:srgbClr val="000000"/>
-                </a:solidFill>
-                <a:latin typeface="Calibri"/>
-              </a:rPr>
-              <a:t/>
-            </a:r>
-            <a:r>
-              <a:rPr b="1" sz="2400">
-                <a:solidFill>
-                  <a:srgbClr val="000000"/>
-                </a:solidFill>
-                <a:latin typeface="Calibri"/>
-              </a:rPr>
-              <a:t>Fidelity Metric: Exact Match (3.2)</a:t>
-            </a:r>
-            <a:r>
-              <a:rPr sz="2400">
-                <a:solidFill>
-                  <a:srgbClr val="000000"/>
-                </a:solidFill>
-                <a:latin typeface="Calibri"/>
-              </a:rPr>
-              <a:t>: Binary indicator of absolute precision.</a:t>
-            </a:r>
-          </a:p>
-          <a:p>
-            <a:pPr>
-              <a:spcAft>
-                <a:spcPts val="1200"/>
-              </a:spcAft>
-            </a:pPr>
-            <a:r>
-              <a:rPr sz="2400">
-                <a:solidFill>
-                  <a:srgbClr val="000000"/>
-                </a:solidFill>
-                <a:latin typeface="Calibri"/>
-              </a:rPr>
-              <a:t/>
-            </a:r>
-            <a:r>
-              <a:rPr b="1" sz="2400">
-                <a:solidFill>
-                  <a:srgbClr val="000000"/>
-                </a:solidFill>
-                <a:latin typeface="Calibri"/>
-              </a:rPr>
-              <a:t>Efficiency Metric: Throughput (3.5)</a:t>
-            </a:r>
-            <a:r>
-              <a:rPr sz="2400">
-                <a:solidFill>
-                  <a:srgbClr val="000000"/>
-                </a:solidFill>
-                <a:latin typeface="Calibri"/>
-              </a:rPr>
-              <a:t>: $T_p = 1/L$</a:t>
-            </a:r>
-          </a:p>
-          <a:p>
-            <a:pPr>
-              <a:spcAft>
-                <a:spcPts val="1200"/>
-              </a:spcAft>
-            </a:pPr>
-            <a:r>
-              <a:rPr sz="2400">
-                <a:solidFill>
-                  <a:srgbClr val="000000"/>
-                </a:solidFill>
-                <a:latin typeface="Calibri"/>
-              </a:rPr>
-              <a:t/>
-            </a:r>
-            <a:r>
-              <a:rPr b="1" sz="2400">
-                <a:solidFill>
-                  <a:srgbClr val="000000"/>
-                </a:solidFill>
-                <a:latin typeface="Calibri"/>
-              </a:rPr>
-              <a:t>Grounding</a:t>
-            </a:r>
-            <a:r>
-              <a:rPr sz="2400">
-                <a:solidFill>
-                  <a:srgbClr val="000000"/>
-                </a:solidFill>
-                <a:latin typeface="Calibri"/>
-              </a:rPr>
-              <a:t>: $s(a_i, g_i) = (1 - NL(a_i, g_i)) \text{ if } NL(a_i, g_i) &lt; 0.5 \text{ else } 0$</a:t>
-            </a:r>
-          </a:p>
-        </p:txBody>
-      </p:sp>
-      <p:sp>
-        <p:nvSpPr>
-          <p:cNvPr id="4" name="TextBox 3"/>
+              <a:rPr b="1" sz="2600">
+                <a:solidFill>
+                  <a:srgbClr val="000000"/>
+                </a:solidFill>
+                <a:latin typeface="Calibri"/>
+              </a:rPr>
+              <a:t>Zero-Shot Protocol</a:t>
+            </a:r>
+            <a:r>
+              <a:rPr sz="2600">
+                <a:solidFill>
+                  <a:srgbClr val="000000"/>
+                </a:solidFill>
+                <a:latin typeface="Calibri"/>
+              </a:rPr>
+              <a:t>: Evaluating robustness without task-specific fine-tuning.</a:t>
+            </a:r>
+          </a:p>
+        </p:txBody>
+      </p:sp>
+      <p:sp>
+        <p:nvSpPr>
+          <p:cNvPr id="4" name="Octagon 3"/>
+          <p:cNvSpPr/>
+          <p:nvPr/>
+        </p:nvSpPr>
+        <p:spPr>
+          <a:xfrm>
+            <a:off x="0" y="6766560"/>
+            <a:ext cx="4063898" cy="91440"/>
+          </a:xfrm>
+          <a:prstGeom prst="octagon">
+            <a:avLst/>
+          </a:prstGeom>
+          <a:solidFill>
+            <a:srgbClr val="003366"/>
+          </a:solidFill>
+          <a:ln>
+            <a:noFill/>
+          </a:ln>
+        </p:spPr>
+        <p:style>
+          <a:lnRef idx="1">
+            <a:schemeClr val="accent1"/>
+          </a:lnRef>
+          <a:fillRef idx="3">
+            <a:schemeClr val="accent1"/>
+          </a:fillRef>
+          <a:effectRef idx="2">
+            <a:schemeClr val="accent1"/>
+          </a:effectRef>
+          <a:fontRef idx="minor">
+            <a:schemeClr val="lt1"/>
+          </a:fontRef>
+        </p:style>
+        <p:txBody>
+          <a:bodyPr rtlCol="0" anchor="ctr"/>
+          <a:lstStyle/>
+          <a:p>
+            <a:pPr algn="ctr"/>
+          </a:p>
+        </p:txBody>
+      </p:sp>
+      <p:sp>
+        <p:nvSpPr>
+          <p:cNvPr id="5" name="TextBox 4"/>
           <p:cNvSpPr txBox="1"/>
           <p:nvPr/>
         </p:nvSpPr>
@@ -4877,42 +5726,18 @@
           <a:lstStyle/>
           <a:p>
             <a:pPr algn="r">
-              <a:defRPr sz="1200">
+              <a:defRPr sz="1000">
                 <a:solidFill>
                   <a:srgbClr val="003366"/>
                 </a:solidFill>
               </a:defRPr>
             </a:pPr>
             <a:r>
-              <a:t>5 / 11</a:t>
-            </a:r>
-          </a:p>
-        </p:txBody>
-      </p:sp>
-      <p:pic>
-        <p:nvPicPr>
-          <p:cNvPr id="5" name="Picture 4" descr="math_5.png"/>
-          <p:cNvPicPr>
-            <a:picLocks noChangeAspect="1"/>
-          </p:cNvPicPr>
-          <p:nvPr/>
-        </p:nvPicPr>
-        <p:blipFill>
-          <a:blip r:embed="rId2"/>
-          <a:stretch>
-            <a:fillRect/>
-          </a:stretch>
-        </p:blipFill>
-        <p:spPr>
-          <a:xfrm>
-            <a:off x="3200400" y="2743200"/>
-            <a:ext cx="5486400" cy="1920240"/>
-          </a:xfrm>
-          <a:prstGeom prst="rect">
-            <a:avLst/>
-          </a:prstGeom>
-        </p:spPr>
-      </p:pic>
+              <a:t>5 / 15</a:t>
+            </a:r>
+          </a:p>
+        </p:txBody>
+      </p:sp>
     </p:spTree>
   </p:cSld>
   <p:clrMapOvr>
@@ -4947,14 +5772,14 @@
           <a:lstStyle/>
           <a:p>
             <a:pPr algn="ctr">
-              <a:defRPr sz="3600" b="1">
+              <a:defRPr sz="3200" b="1">
                 <a:solidFill>
                   <a:srgbClr val="003366"/>
                 </a:solidFill>
               </a:defRPr>
             </a:pPr>
             <a:r>
-              <a:t>Benchmarking Results: The Accuracy-Efficiency Frontier</a:t>
+              <a:t>Mathematical Formalization of Reliability</a:t>
             </a:r>
           </a:p>
         </p:txBody>
@@ -4971,8 +5796,8 @@
         </p:nvSpPr>
         <p:spPr>
           <a:xfrm>
-            <a:off x="457200" y="1645920"/>
-            <a:ext cx="5943600" cy="0"/>
+            <a:off x="548640" y="5943600"/>
+            <a:ext cx="10972800" cy="0"/>
           </a:xfrm>
         </p:spPr>
         <p:txBody>
@@ -4980,13 +5805,13 @@
           <a:lstStyle/>
           <a:p/>
           <a:p>
-            <a:pPr>
+            <a:pPr algn="ctr">
               <a:spcAft>
-                <a:spcPts val="1200"/>
+                <a:spcPts val="1400"/>
               </a:spcAft>
             </a:pPr>
             <a:r>
-              <a:rPr sz="2400">
+              <a:rPr sz="2200">
                 <a:solidFill>
                   <a:srgbClr val="000000"/>
                 </a:solidFill>
@@ -4995,32 +5820,32 @@
               <a:t/>
             </a:r>
             <a:r>
-              <a:rPr b="1" sz="2400">
-                <a:solidFill>
-                  <a:srgbClr val="000000"/>
-                </a:solidFill>
-                <a:latin typeface="Calibri"/>
-              </a:rPr>
-              <a:t>Performance Delta</a:t>
-            </a:r>
-            <a:r>
-              <a:rPr sz="2400">
-                <a:solidFill>
-                  <a:srgbClr val="000000"/>
-                </a:solidFill>
-                <a:latin typeface="Calibri"/>
-              </a:rPr>
-              <a:t>: The Hybrid model achieves higher ANLS scores over standalone VLMs in dense tabular environments.</a:t>
-            </a:r>
-          </a:p>
-          <a:p>
-            <a:pPr>
+              <a:rPr b="1" sz="2200">
+                <a:solidFill>
+                  <a:srgbClr val="000000"/>
+                </a:solidFill>
+                <a:latin typeface="Calibri"/>
+              </a:rPr>
+              <a:t>Hybrid Synchronization</a:t>
+            </a:r>
+            <a:r>
+              <a:rPr sz="2200">
+                <a:solidFill>
+                  <a:srgbClr val="000000"/>
+                </a:solidFill>
+                <a:latin typeface="Calibri"/>
+              </a:rPr>
+              <a:t>: $C = S_{ocr} \parallel S_{vlm}$</a:t>
+            </a:r>
+          </a:p>
+          <a:p>
+            <a:pPr algn="ctr">
               <a:spcAft>
-                <a:spcPts val="1200"/>
+                <a:spcPts val="1400"/>
               </a:spcAft>
             </a:pPr>
             <a:r>
-              <a:rPr sz="2400">
+              <a:rPr sz="2200">
                 <a:solidFill>
                   <a:srgbClr val="000000"/>
                 </a:solidFill>
@@ -5029,29 +5854,106 @@
               <a:t/>
             </a:r>
             <a:r>
-              <a:rPr b="1" sz="2400">
-                <a:solidFill>
-                  <a:srgbClr val="000000"/>
-                </a:solidFill>
-                <a:latin typeface="Calibri"/>
-              </a:rPr>
-              <a:t>Observation</a:t>
-            </a:r>
-            <a:r>
-              <a:rPr sz="2400">
-                <a:solidFill>
-                  <a:srgbClr val="000000"/>
-                </a:solidFill>
-                <a:latin typeface="Calibri"/>
-              </a:rPr>
-              <a:t>: Improving perception fidelity requires a significant computational trade-off in inference latency.</a:t>
-            </a:r>
-          </a:p>
-        </p:txBody>
-      </p:sp>
-      <p:sp>
-        <p:nvSpPr>
-          <p:cNvPr id="4" name="TextBox 3"/>
+              <a:rPr b="1" sz="2200">
+                <a:solidFill>
+                  <a:srgbClr val="000000"/>
+                </a:solidFill>
+                <a:latin typeface="Calibri"/>
+              </a:rPr>
+              <a:t>Accuracy Metric: ANLS</a:t>
+            </a:r>
+            <a:r>
+              <a:rPr sz="2200">
+                <a:solidFill>
+                  <a:srgbClr val="000000"/>
+                </a:solidFill>
+                <a:latin typeface="Calibri"/>
+              </a:rPr>
+              <a:t>:</a:t>
+            </a:r>
+          </a:p>
+          <a:p>
+            <a:pPr algn="ctr">
+              <a:spcAft>
+                <a:spcPts val="1400"/>
+              </a:spcAft>
+            </a:pPr>
+            <a:r>
+              <a:rPr sz="2200">
+                <a:solidFill>
+                  <a:srgbClr val="000000"/>
+                </a:solidFill>
+                <a:latin typeface="Calibri"/>
+              </a:rPr>
+              <a:t/>
+            </a:r>
+            <a:r>
+              <a:rPr b="1" sz="2200">
+                <a:solidFill>
+                  <a:srgbClr val="000000"/>
+                </a:solidFill>
+                <a:latin typeface="Calibri"/>
+              </a:rPr>
+              <a:t>Fidelity Metric: Exact Match</a:t>
+            </a:r>
+            <a:r>
+              <a:rPr sz="2200">
+                <a:solidFill>
+                  <a:srgbClr val="000000"/>
+                </a:solidFill>
+                <a:latin typeface="Calibri"/>
+              </a:rPr>
+              <a:t>: Binary indicator of absolute precision.</a:t>
+            </a:r>
+          </a:p>
+        </p:txBody>
+      </p:sp>
+      <p:sp>
+        <p:nvSpPr>
+          <p:cNvPr id="4" name="Octagon 3"/>
+          <p:cNvSpPr/>
+          <p:nvPr/>
+        </p:nvSpPr>
+        <p:spPr>
+          <a:xfrm>
+            <a:off x="0" y="6766560"/>
+            <a:ext cx="4876678" cy="91440"/>
+          </a:xfrm>
+          <a:prstGeom prst="octagon">
+            <a:avLst/>
+          </a:prstGeom>
+          <a:solidFill>
+            <a:srgbClr val="003366"/>
+          </a:solidFill>
+          <a:ln>
+            <a:noFill/>
+          </a:ln>
+        </p:spPr>
+        <p:style>
+          <a:lnRef idx="1">
+            <a:schemeClr val="accent1"/>
+          </a:lnRef>
+          <a:fillRef idx="3">
+            <a:schemeClr val="accent1"/>
+          </a:fillRef>
+          <a:effectRef idx="2">
+            <a:schemeClr val="accent1"/>
+          </a:effectRef>
+          <a:fontRef idx="minor">
+            <a:schemeClr val="lt1"/>
+          </a:fontRef>
+        </p:style>
+        <p:txBody>
+          <a:bodyPr rtlCol="0" anchor="ctr"/>
+          <a:lstStyle/>
+          <a:p>
+            <a:pPr algn="ctr"/>
+          </a:p>
+        </p:txBody>
+      </p:sp>
+      <p:sp>
+        <p:nvSpPr>
+          <p:cNvPr id="5" name="TextBox 4"/>
           <p:cNvSpPr txBox="1"/>
           <p:nvPr/>
         </p:nvSpPr>
@@ -5072,21 +5974,21 @@
           <a:lstStyle/>
           <a:p>
             <a:pPr algn="r">
-              <a:defRPr sz="1200">
+              <a:defRPr sz="1000">
                 <a:solidFill>
                   <a:srgbClr val="003366"/>
                 </a:solidFill>
               </a:defRPr>
             </a:pPr>
             <a:r>
-              <a:t>6 / 11</a:t>
+              <a:t>6 / 15</a:t>
             </a:r>
           </a:p>
         </p:txBody>
       </p:sp>
       <p:pic>
         <p:nvPicPr>
-          <p:cNvPr id="5" name="Picture 4" descr="accuracy_tradeoff.png"/>
+          <p:cNvPr id="6" name="Picture 5" descr="math_6.png"/>
           <p:cNvPicPr>
             <a:picLocks noChangeAspect="1"/>
           </p:cNvPicPr>
@@ -5100,8 +6002,8 @@
         </p:blipFill>
         <p:spPr>
           <a:xfrm>
-            <a:off x="6583680" y="1828800"/>
-            <a:ext cx="5029200" cy="5486400"/>
+            <a:off x="1843887" y="2286000"/>
+            <a:ext cx="8503920" cy="2632663"/>
           </a:xfrm>
           <a:prstGeom prst="rect">
             <a:avLst/>
@@ -5142,14 +6044,14 @@
           <a:lstStyle/>
           <a:p>
             <a:pPr algn="ctr">
-              <a:defRPr sz="3600" b="1">
+              <a:defRPr sz="3200" b="1">
                 <a:solidFill>
                   <a:srgbClr val="003366"/>
                 </a:solidFill>
               </a:defRPr>
             </a:pPr>
             <a:r>
-              <a:t>Quantitative Evidence: Efficiency &amp; Memory</a:t>
+              <a:t>The Accuracy-Efficiency Frontier</a:t>
             </a:r>
           </a:p>
         </p:txBody>
@@ -5164,89 +6066,59 @@
             <p:ph idx="1"/>
           </p:nvPr>
         </p:nvSpPr>
-        <p:spPr>
-          <a:xfrm>
-            <a:off x="457200" y="1645920"/>
-            <a:ext cx="5943600" cy="0"/>
-          </a:xfrm>
-        </p:spPr>
+        <p:spPr/>
         <p:txBody>
           <a:bodyPr/>
           <a:lstStyle/>
           <a:p/>
-          <a:p>
-            <a:pPr>
-              <a:spcAft>
-                <a:spcPts val="1200"/>
-              </a:spcAft>
-            </a:pPr>
-            <a:r>
-              <a:rPr sz="2400">
-                <a:solidFill>
-                  <a:srgbClr val="000000"/>
-                </a:solidFill>
-                <a:latin typeface="Calibri"/>
-              </a:rPr>
-              <a:t/>
-            </a:r>
-            <a:r>
-              <a:rPr b="1" sz="2400">
-                <a:solidFill>
-                  <a:srgbClr val="000000"/>
-                </a:solidFill>
-                <a:latin typeface="Calibri"/>
-              </a:rPr>
-              <a:t>Throughput Inversion</a:t>
-            </a:r>
-            <a:r>
-              <a:rPr sz="2400">
-                <a:solidFill>
-                  <a:srgbClr val="000000"/>
-                </a:solidFill>
-                <a:latin typeface="Calibri"/>
-              </a:rPr>
-              <a:t>: While VLMs provide higher throughput, their reliability in zero-shot extractions is significantly lower than grounded hybrid architectures.</a:t>
-            </a:r>
-          </a:p>
-          <a:p>
-            <a:pPr>
-              <a:spcAft>
-                <a:spcPts val="1200"/>
-              </a:spcAft>
-            </a:pPr>
-            <a:r>
-              <a:rPr sz="2400">
-                <a:solidFill>
-                  <a:srgbClr val="000000"/>
-                </a:solidFill>
-                <a:latin typeface="Calibri"/>
-              </a:rPr>
-              <a:t/>
-            </a:r>
-            <a:r>
-              <a:rPr b="1" sz="2400">
-                <a:solidFill>
-                  <a:srgbClr val="000000"/>
-                </a:solidFill>
-                <a:latin typeface="Calibri"/>
-              </a:rPr>
-              <a:t>Resource Footprint</a:t>
-            </a:r>
-            <a:r>
-              <a:rPr sz="2400">
-                <a:solidFill>
-                  <a:srgbClr val="000000"/>
-                </a:solidFill>
-                <a:latin typeface="Calibri"/>
-              </a:rPr>
-              <a:t>: Hybrid models demand higher memory (RSS) due to dual-stream synchronization overhead.</a:t>
-            </a:r>
-          </a:p>
-        </p:txBody>
-      </p:sp>
-      <p:sp>
-        <p:nvSpPr>
-          <p:cNvPr id="4" name="TextBox 3"/>
+        </p:txBody>
+      </p:sp>
+      <p:sp>
+        <p:nvSpPr>
+          <p:cNvPr id="4" name="Octagon 3"/>
+          <p:cNvSpPr/>
+          <p:nvPr/>
+        </p:nvSpPr>
+        <p:spPr>
+          <a:xfrm>
+            <a:off x="0" y="6766560"/>
+            <a:ext cx="5689457" cy="91440"/>
+          </a:xfrm>
+          <a:prstGeom prst="octagon">
+            <a:avLst/>
+          </a:prstGeom>
+          <a:solidFill>
+            <a:srgbClr val="003366"/>
+          </a:solidFill>
+          <a:ln>
+            <a:noFill/>
+          </a:ln>
+        </p:spPr>
+        <p:style>
+          <a:lnRef idx="1">
+            <a:schemeClr val="accent1"/>
+          </a:lnRef>
+          <a:fillRef idx="3">
+            <a:schemeClr val="accent1"/>
+          </a:fillRef>
+          <a:effectRef idx="2">
+            <a:schemeClr val="accent1"/>
+          </a:effectRef>
+          <a:fontRef idx="minor">
+            <a:schemeClr val="lt1"/>
+          </a:fontRef>
+        </p:style>
+        <p:txBody>
+          <a:bodyPr rtlCol="0" anchor="ctr"/>
+          <a:lstStyle/>
+          <a:p>
+            <a:pPr algn="ctr"/>
+          </a:p>
+        </p:txBody>
+      </p:sp>
+      <p:sp>
+        <p:nvSpPr>
+          <p:cNvPr id="5" name="TextBox 4"/>
           <p:cNvSpPr txBox="1"/>
           <p:nvPr/>
         </p:nvSpPr>
@@ -5267,21 +6139,21 @@
           <a:lstStyle/>
           <a:p>
             <a:pPr algn="r">
-              <a:defRPr sz="1200">
+              <a:defRPr sz="1000">
                 <a:solidFill>
                   <a:srgbClr val="003366"/>
                 </a:solidFill>
               </a:defRPr>
             </a:pPr>
             <a:r>
-              <a:t>7 / 11</a:t>
+              <a:t>7 / 15</a:t>
             </a:r>
           </a:p>
         </p:txBody>
       </p:sp>
       <p:pic>
         <p:nvPicPr>
-          <p:cNvPr id="5" name="Picture 4" descr="efficiency_comparison.png"/>
+          <p:cNvPr id="6" name="Picture 5" descr="accuracy_tradeoff.png"/>
           <p:cNvPicPr>
             <a:picLocks noChangeAspect="1"/>
           </p:cNvPicPr>
@@ -5295,8 +6167,8 @@
         </p:blipFill>
         <p:spPr>
           <a:xfrm>
-            <a:off x="6583680" y="1828800"/>
-            <a:ext cx="5029200" cy="5486400"/>
+            <a:off x="1386687" y="1645920"/>
+            <a:ext cx="9418320" cy="4572000"/>
           </a:xfrm>
           <a:prstGeom prst="rect">
             <a:avLst/>
@@ -5337,14 +6209,14 @@
           <a:lstStyle/>
           <a:p>
             <a:pPr algn="ctr">
-              <a:defRPr sz="3600" b="1">
+              <a:defRPr sz="3200" b="1">
                 <a:solidFill>
                   <a:srgbClr val="003366"/>
                 </a:solidFill>
               </a:defRPr>
             </a:pPr>
             <a:r>
-              <a:t>Qualitative Analysis: Visualizing Failure Modes</a:t>
+              <a:t>Benchmarking Results: Performance Delta</a:t>
             </a:r>
           </a:p>
         </p:txBody>
@@ -5361,8 +6233,8 @@
         </p:nvSpPr>
         <p:spPr>
           <a:xfrm>
-            <a:off x="457200" y="1645920"/>
-            <a:ext cx="5943600" cy="0"/>
+            <a:off x="822960" y="1645920"/>
+            <a:ext cx="10515600" cy="0"/>
           </a:xfrm>
         </p:spPr>
         <p:txBody>
@@ -5370,13 +6242,13 @@
           <a:lstStyle/>
           <a:p/>
           <a:p>
-            <a:pPr>
+            <a:pPr algn="l">
               <a:spcAft>
-                <a:spcPts val="1200"/>
+                <a:spcPts val="1400"/>
               </a:spcAft>
             </a:pPr>
             <a:r>
-              <a:rPr sz="2400">
+              <a:rPr sz="2600">
                 <a:solidFill>
                   <a:srgbClr val="000000"/>
                 </a:solidFill>
@@ -5385,32 +6257,32 @@
               <a:t/>
             </a:r>
             <a:r>
-              <a:rPr b="1" sz="2400">
-                <a:solidFill>
-                  <a:srgbClr val="000000"/>
-                </a:solidFill>
-                <a:latin typeface="Calibri"/>
-              </a:rPr>
-              <a:t>VLM Failure</a:t>
-            </a:r>
-            <a:r>
-              <a:rPr sz="2400">
-                <a:solidFill>
-                  <a:srgbClr val="000000"/>
-                </a:solidFill>
-                <a:latin typeface="Calibri"/>
-              </a:rPr>
-              <a:t>: Resolution-loss causes rounding errors and "probabilistic guessing" in financial figures.</a:t>
-            </a:r>
-          </a:p>
-          <a:p>
-            <a:pPr>
+              <a:rPr b="1" sz="2600">
+                <a:solidFill>
+                  <a:srgbClr val="000000"/>
+                </a:solidFill>
+                <a:latin typeface="Calibri"/>
+              </a:rPr>
+              <a:t>Observation</a:t>
+            </a:r>
+            <a:r>
+              <a:rPr sz="2600">
+                <a:solidFill>
+                  <a:srgbClr val="000000"/>
+                </a:solidFill>
+                <a:latin typeface="Calibri"/>
+              </a:rPr>
+              <a:t>: The Hybrid model achieves significantly higher ANLS scores over standalone VLMs in dense tabular environments.</a:t>
+            </a:r>
+          </a:p>
+          <a:p>
+            <a:pPr algn="l">
               <a:spcAft>
-                <a:spcPts val="1200"/>
+                <a:spcPts val="1400"/>
               </a:spcAft>
             </a:pPr>
             <a:r>
-              <a:rPr sz="2400">
+              <a:rPr sz="2600">
                 <a:solidFill>
                   <a:srgbClr val="000000"/>
                 </a:solidFill>
@@ -5419,29 +6291,72 @@
               <a:t/>
             </a:r>
             <a:r>
-              <a:rPr b="1" sz="2400">
-                <a:solidFill>
-                  <a:srgbClr val="000000"/>
-                </a:solidFill>
-                <a:latin typeface="Calibri"/>
-              </a:rPr>
-              <a:t>Hybrid Remediation</a:t>
-            </a:r>
-            <a:r>
-              <a:rPr sz="2400">
-                <a:solidFill>
-                  <a:srgbClr val="000000"/>
-                </a:solidFill>
-                <a:latin typeface="Calibri"/>
-              </a:rPr>
-              <a:t>: Deterministic OCR grounding recovers exact alphanumeric sequences ($1,240.50$ vs $1,200.00$).</a:t>
-            </a:r>
-          </a:p>
-        </p:txBody>
-      </p:sp>
-      <p:sp>
-        <p:nvSpPr>
-          <p:cNvPr id="4" name="TextBox 3"/>
+              <a:rPr b="1" sz="2600">
+                <a:solidFill>
+                  <a:srgbClr val="000000"/>
+                </a:solidFill>
+                <a:latin typeface="Calibri"/>
+              </a:rPr>
+              <a:t>Trade-off</a:t>
+            </a:r>
+            <a:r>
+              <a:rPr sz="2600">
+                <a:solidFill>
+                  <a:srgbClr val="000000"/>
+                </a:solidFill>
+                <a:latin typeface="Calibri"/>
+              </a:rPr>
+              <a:t>: Improving perception fidelity requires a significant computational trade-off in inference latency.</a:t>
+            </a:r>
+          </a:p>
+        </p:txBody>
+      </p:sp>
+      <p:sp>
+        <p:nvSpPr>
+          <p:cNvPr id="4" name="Octagon 3"/>
+          <p:cNvSpPr/>
+          <p:nvPr/>
+        </p:nvSpPr>
+        <p:spPr>
+          <a:xfrm>
+            <a:off x="0" y="6766560"/>
+            <a:ext cx="6502237" cy="91440"/>
+          </a:xfrm>
+          <a:prstGeom prst="octagon">
+            <a:avLst/>
+          </a:prstGeom>
+          <a:solidFill>
+            <a:srgbClr val="003366"/>
+          </a:solidFill>
+          <a:ln>
+            <a:noFill/>
+          </a:ln>
+        </p:spPr>
+        <p:style>
+          <a:lnRef idx="1">
+            <a:schemeClr val="accent1"/>
+          </a:lnRef>
+          <a:fillRef idx="3">
+            <a:schemeClr val="accent1"/>
+          </a:fillRef>
+          <a:effectRef idx="2">
+            <a:schemeClr val="accent1"/>
+          </a:effectRef>
+          <a:fontRef idx="minor">
+            <a:schemeClr val="lt1"/>
+          </a:fontRef>
+        </p:style>
+        <p:txBody>
+          <a:bodyPr rtlCol="0" anchor="ctr"/>
+          <a:lstStyle/>
+          <a:p>
+            <a:pPr algn="ctr"/>
+          </a:p>
+        </p:txBody>
+      </p:sp>
+      <p:sp>
+        <p:nvSpPr>
+          <p:cNvPr id="5" name="TextBox 4"/>
           <p:cNvSpPr txBox="1"/>
           <p:nvPr/>
         </p:nvSpPr>
@@ -5462,42 +6377,18 @@
           <a:lstStyle/>
           <a:p>
             <a:pPr algn="r">
-              <a:defRPr sz="1200">
+              <a:defRPr sz="1000">
                 <a:solidFill>
                   <a:srgbClr val="003366"/>
                 </a:solidFill>
               </a:defRPr>
             </a:pPr>
             <a:r>
-              <a:t>8 / 11</a:t>
-            </a:r>
-          </a:p>
-        </p:txBody>
-      </p:sp>
-      <p:pic>
-        <p:nvPicPr>
-          <p:cNvPr id="5" name="Picture 4" descr="hallucination_comparison.png"/>
-          <p:cNvPicPr>
-            <a:picLocks noChangeAspect="1"/>
-          </p:cNvPicPr>
-          <p:nvPr/>
-        </p:nvPicPr>
-        <p:blipFill>
-          <a:blip r:embed="rId2"/>
-          <a:stretch>
-            <a:fillRect/>
-          </a:stretch>
-        </p:blipFill>
-        <p:spPr>
-          <a:xfrm>
-            <a:off x="6583680" y="1828800"/>
-            <a:ext cx="5029200" cy="3121152"/>
-          </a:xfrm>
-          <a:prstGeom prst="rect">
-            <a:avLst/>
-          </a:prstGeom>
-        </p:spPr>
-      </p:pic>
+              <a:t>8 / 15</a:t>
+            </a:r>
+          </a:p>
+        </p:txBody>
+      </p:sp>
     </p:spTree>
   </p:cSld>
   <p:clrMapOvr>

</xml_diff>